<commit_message>
Update presentation deck to the version with embedded screenshots
Replaces the generated screenshot-less deck with the author's version that
embeds the five app screenshots (LEON verified/mismatch, Mode A, Druggability,
Compare) on the Capabilities, LEON, and Evaluation slides.
</commit_message>
<xml_diff>
--- a/ist362_copilot/presentation/SOLANGE_Copilot_presentation.pptx
+++ b/ist362_copilot/presentation/SOLANGE_Copilot_presentation.pptx
@@ -4,6 +4,9 @@
   <p:sldMasterIdLst>
     <p:sldMasterId id="2147483648" r:id="rId1"/>
   </p:sldMasterIdLst>
+  <p:notesMasterIdLst>
+    <p:notesMasterId r:id="rId13"/>
+  </p:notesMasterIdLst>
   <p:sldIdLst>
     <p:sldId id="256" r:id="rId2"/>
     <p:sldId id="257" r:id="rId3"/>
@@ -17,9 +20,6 @@
     <p:sldId id="265" r:id="rId11"/>
     <p:sldId id="266" r:id="rId12"/>
   </p:sldIdLst>
-  <p:notesMasterIdLst>
-    <p:notesMasterId r:id="rId13"/>
-  </p:notesMasterIdLst>
   <p:sldSz cx="12192000" cy="6858000"/>
   <p:notesSz cx="6858000" cy="12192000"/>
   <p:defaultTextStyle>
@@ -114,13 +114,20 @@
       </a:defRPr>
     </a:lvl9pPr>
   </p:defaultTextStyle>
+  <p:extLst>
+    <p:ext uri="{EFAFB233-063F-42B5-8137-9DF3F51BA10A}">
+      <p15:sldGuideLst xmlns:p15="http://schemas.microsoft.com/office/powerpoint/2012/main"/>
+    </p:ext>
+  </p:extLst>
 </p:presentation>
 </file>
 
 <file path=ppt/charts/chart1.xml><?xml version="1.0" encoding="utf-8"?>
-<c:chartSpace xmlns:c="http://schemas.openxmlformats.org/drawingml/2006/chart" xmlns:a="http://schemas.openxmlformats.org/drawingml/2006/main" xmlns:r="http://schemas.openxmlformats.org/officeDocument/2006/relationships">
+<c:chartSpace xmlns:c="http://schemas.openxmlformats.org/drawingml/2006/chart" xmlns:a="http://schemas.openxmlformats.org/drawingml/2006/main" xmlns:r="http://schemas.openxmlformats.org/officeDocument/2006/relationships" xmlns:c16r2="http://schemas.microsoft.com/office/drawing/2015/06/chart">
   <c:date1904 val="0"/>
+  <c:lang val="en-US"/>
   <c:roundedCorners val="1"/>
+  <c:style val="2"/>
   <c:chart>
     <c:title>
       <c:tx>
@@ -137,18 +144,17 @@
               </a:defRPr>
             </a:pPr>
             <a:r>
-              <a:rPr sz="1300" b="0" i="0" u="none" strike="noStrike">
+              <a:rPr lang="en-US" sz="1300" b="0" i="0" u="none" strike="noStrike" dirty="0">
                 <a:solidFill>
                   <a:srgbClr val="F1F5F9"/>
                 </a:solidFill>
                 <a:latin typeface="Calibri"/>
               </a:rPr>
-              <a:t>Mean latency per query (s) — lower is better</a:t>
+              <a:t>Mean latency per query (s) - lower is better</a:t>
             </a:r>
           </a:p>
         </c:rich>
       </c:tx>
-      <c:layout/>
       <c:overlay val="0"/>
     </c:title>
     <c:autoTitleDeleted val="0"/>
@@ -183,18 +189,26 @@
           <c:invertIfNegative val="0"/>
           <c:dLbls>
             <c:numFmt formatCode="#,##0" sourceLinked="0"/>
+            <c:spPr>
+              <a:noFill/>
+              <a:ln>
+                <a:noFill/>
+              </a:ln>
+              <a:effectLst/>
+            </c:spPr>
             <c:txPr>
               <a:bodyPr/>
               <a:lstStyle/>
               <a:p>
                 <a:pPr>
-                  <a:defRPr b="0" i="0" strike="noStrike" sz="1200" u="none">
+                  <a:defRPr sz="1200" b="0" i="0" u="none" strike="noStrike">
                     <a:solidFill>
                       <a:srgbClr val="F1F5F9"/>
                     </a:solidFill>
                     <a:latin typeface="Calibri"/>
                   </a:defRPr>
                 </a:pPr>
+                <a:endParaRPr lang="en-US"/>
               </a:p>
             </c:txPr>
             <c:showLegendKey val="0"/>
@@ -204,28 +218,31 @@
             <c:showPercent val="0"/>
             <c:showBubbleSize val="0"/>
             <c:showLeaderLines val="0"/>
+            <c:extLst>
+              <c:ext xmlns:c15="http://schemas.microsoft.com/office/drawing/2012/chart" uri="{CE6537A1-D6FC-4f65-9D91-7224C49458BB}">
+                <c15:showLeaderLines val="0"/>
+              </c:ext>
+            </c:extLst>
           </c:dLbls>
           <c:cat>
-            <c:multiLvlStrRef>
+            <c:strRef>
               <c:f>Sheet1!$A$2:$A$5</c:f>
-              <c:multiLvlStrCache>
+              <c:strCache>
                 <c:ptCount val="4"/>
-                <c:lvl>
-                  <c:pt idx="0">
-                    <c:v>llama3.2 (3B)</c:v>
-                  </c:pt>
-                  <c:pt idx="1">
-                    <c:v>qwen3:0.6b</c:v>
-                  </c:pt>
-                  <c:pt idx="2">
-                    <c:v>deepseek-r1:1.5b</c:v>
-                  </c:pt>
-                  <c:pt idx="3">
-                    <c:v>deepseek-r1:8b</c:v>
-                  </c:pt>
-                </c:lvl>
-              </c:multiLvlStrCache>
-            </c:multiLvlStrRef>
+                <c:pt idx="0">
+                  <c:v>llama3.2 (3B)</c:v>
+                </c:pt>
+                <c:pt idx="1">
+                  <c:v>qwen3:0.6b</c:v>
+                </c:pt>
+                <c:pt idx="2">
+                  <c:v>deepseek-r1:1.5b</c:v>
+                </c:pt>
+                <c:pt idx="3">
+                  <c:v>deepseek-r1:8b</c:v>
+                </c:pt>
+              </c:strCache>
+            </c:strRef>
           </c:cat>
           <c:val>
             <c:numRef>
@@ -240,7 +257,7 @@
                   <c:v>1.62</c:v>
                 </c:pt>
                 <c:pt idx="2">
-                  <c:v>4.77</c:v>
+                  <c:v>4.7699999999999996</c:v>
                 </c:pt>
                 <c:pt idx="3">
                   <c:v>13.62</c:v>
@@ -248,36 +265,23 @@
               </c:numCache>
             </c:numRef>
           </c:val>
+          <c:extLst>
+            <c:ext xmlns:c16="http://schemas.microsoft.com/office/drawing/2014/chart" uri="{C3380CC4-5D6E-409C-BE32-E72D297353CC}">
+              <c16:uniqueId val="{00000000-842D-AE4C-80E5-DC2DC080502B}"/>
+            </c:ext>
+          </c:extLst>
         </c:ser>
         <c:dLbls>
-          <c:numFmt formatCode="#,##0" sourceLinked="0"/>
-          <c:txPr>
-            <a:bodyPr/>
-            <a:lstStyle/>
-            <a:p>
-              <a:pPr>
-                <a:defRPr b="0" i="0" strike="noStrike" sz="1200" u="none">
-                  <a:solidFill>
-                    <a:srgbClr val="F1F5F9"/>
-                  </a:solidFill>
-                  <a:latin typeface="Calibri"/>
-                </a:defRPr>
-              </a:pPr>
-            </a:p>
-          </c:txPr>
           <c:showLegendKey val="0"/>
           <c:showVal val="1"/>
           <c:showCatName val="0"/>
           <c:showSerName val="0"/>
           <c:showPercent val="0"/>
           <c:showBubbleSize val="0"/>
-          <c:showLeaderLines val="0"/>
         </c:dLbls>
         <c:gapWidth val="150"/>
-        <c:overlap val="0"/>
         <c:axId val="2094734554"/>
         <c:axId val="2094734552"/>
-        <c:axId val="2094734556"/>
       </c:barChart>
       <c:catAx>
         <c:axId val="2094734554"/>
@@ -318,6 +322,7 @@
         <c:crosses val="autoZero"/>
         <c:auto val="1"/>
         <c:lblAlgn val="ctr"/>
+        <c:lblOffset val="100"/>
         <c:noMultiLvlLbl val="1"/>
       </c:catAx>
       <c:valAx>
@@ -331,30 +336,6 @@
         <c:majorTickMark val="out"/>
         <c:minorTickMark val="none"/>
         <c:tickLblPos val="low"/>
-        <c:spPr>
-          <a:ln w="12700" cap="flat">
-            <a:solidFill>
-              <a:srgbClr val="888888"/>
-            </a:solidFill>
-            <a:prstDash val="solid"/>
-            <a:round/>
-          </a:ln>
-        </c:spPr>
-        <c:txPr>
-          <a:bodyPr/>
-          <a:lstStyle/>
-          <a:p>
-            <a:pPr>
-              <a:defRPr sz="1200" b="0" i="0" u="none" strike="noStrike">
-                <a:solidFill>
-                  <a:srgbClr val="000000"/>
-                </a:solidFill>
-                <a:latin typeface="Arial"/>
-              </a:defRPr>
-            </a:pPr>
-            <a:endParaRPr lang="en-US"/>
-          </a:p>
-        </c:txPr>
         <c:crossAx val="2094734554"/>
         <c:crosses val="autoZero"/>
         <c:crossBetween val="between"/>
@@ -369,6 +350,7 @@
     </c:plotArea>
     <c:plotVisOnly val="1"/>
     <c:dispBlanksAs val="span"/>
+    <c:showDLblsOverMax val="1"/>
   </c:chart>
   <c:spPr>
     <a:noFill/>
@@ -405,234 +387,10 @@
           <a:chExt cx="0" cy="0"/>
         </a:xfrm>
       </p:grpSpPr>
-      <p:sp>
-        <p:nvSpPr>
-          <p:cNvPr id="2" name="Header Placeholder 1"/>
-          <p:cNvSpPr>
-            <a:spLocks noGrp="1"/>
-          </p:cNvSpPr>
-          <p:nvPr>
-            <p:ph type="hdr" sz="quarter"/>
-          </p:nvPr>
-        </p:nvSpPr>
-        <p:spPr>
-          <a:xfrm>
-            <a:off x="0" y="0"/>
-            <a:ext cx="2971800" cy="458788"/>
-          </a:xfrm>
-          <a:prstGeom prst="rect">
-            <a:avLst/>
-          </a:prstGeom>
-        </p:spPr>
-        <p:txBody>
-          <a:bodyPr vert="horz" lIns="91440" tIns="45720" rIns="91440" bIns="45720" rtlCol="0"/>
-          <a:lstStyle>
-            <a:lvl1pPr algn="l">
-              <a:defRPr sz="1200"/>
-            </a:lvl1pPr>
-          </a:lstStyle>
-          <a:p>
-            <a:endParaRPr lang="en-US"/>
-          </a:p>
-        </p:txBody>
-      </p:sp>
-      <p:sp>
-        <p:nvSpPr>
-          <p:cNvPr id="3" name="Date Placeholder 2"/>
-          <p:cNvSpPr>
-            <a:spLocks noGrp="1"/>
-          </p:cNvSpPr>
-          <p:nvPr>
-            <p:ph type="dt" idx="1"/>
-          </p:nvPr>
-        </p:nvSpPr>
-        <p:spPr>
-          <a:xfrm>
-            <a:off x="3884613" y="0"/>
-            <a:ext cx="2971800" cy="458788"/>
-          </a:xfrm>
-          <a:prstGeom prst="rect">
-            <a:avLst/>
-          </a:prstGeom>
-        </p:spPr>
-        <p:txBody>
-          <a:bodyPr vert="horz" lIns="91440" tIns="45720" rIns="91440" bIns="45720" rtlCol="0"/>
-          <a:lstStyle>
-            <a:lvl1pPr algn="r">
-              <a:defRPr sz="1200"/>
-            </a:lvl1pPr>
-          </a:lstStyle>
-          <a:p>
-            <a:fld id="{5282F153-3F37-0F45-9E97-73ACFA13230C}" type="datetimeFigureOut">
-              <a:rPr lang="en-US"/>
-              <a:t>7/23/19</a:t>
-            </a:fld>
-            <a:endParaRPr lang="en-US"/>
-          </a:p>
-        </p:txBody>
-      </p:sp>
-      <p:sp>
-        <p:nvSpPr>
-          <p:cNvPr id="4" name="Slide Image Placeholder 3"/>
-          <p:cNvSpPr>
-            <a:spLocks noGrp="1" noRot="1" noChangeAspect="1"/>
-          </p:cNvSpPr>
-          <p:nvPr>
-            <p:ph type="sldImg" idx="2"/>
-          </p:nvPr>
-        </p:nvSpPr>
-        <p:spPr>
-          <a:xfrm>
-            <a:off x="685800" y="1143000"/>
-            <a:ext cx="5486400" cy="3086100"/>
-          </a:xfrm>
-          <a:prstGeom prst="rect">
-            <a:avLst/>
-          </a:prstGeom>
-          <a:noFill/>
-          <a:ln w="12700">
-            <a:solidFill>
-              <a:prstClr val="black"/>
-            </a:solidFill>
-          </a:ln>
-        </p:spPr>
-        <p:txBody>
-          <a:bodyPr vert="horz" lIns="91440" tIns="45720" rIns="91440" bIns="45720" rtlCol="0" anchor="ctr"/>
-          <a:lstStyle/>
-          <a:p>
-            <a:endParaRPr lang="en-US"/>
-          </a:p>
-        </p:txBody>
-      </p:sp>
-      <p:sp>
-        <p:nvSpPr>
-          <p:cNvPr id="5" name="Notes Placeholder 4"/>
-          <p:cNvSpPr>
-            <a:spLocks noGrp="1"/>
-          </p:cNvSpPr>
-          <p:nvPr>
-            <p:ph type="body" sz="quarter" idx="3"/>
-          </p:nvPr>
-        </p:nvSpPr>
-        <p:spPr>
-          <a:xfrm>
-            <a:off x="685800" y="4400550"/>
-            <a:ext cx="5486400" cy="3600450"/>
-          </a:xfrm>
-          <a:prstGeom prst="rect">
-            <a:avLst/>
-          </a:prstGeom>
-        </p:spPr>
-        <p:txBody>
-          <a:bodyPr vert="horz" lIns="91440" tIns="45720" rIns="91440" bIns="45720" rtlCol="0"/>
-          <a:lstStyle/>
-          <a:p>
-            <a:pPr lvl="0"/>
-            <a:r>
-              <a:rPr lang="en-US"/>
-              <a:t>Click to edit Master text styles</a:t>
-            </a:r>
-          </a:p>
-          <a:p>
-            <a:pPr lvl="1"/>
-            <a:r>
-              <a:rPr lang="en-US"/>
-              <a:t>Second level</a:t>
-            </a:r>
-          </a:p>
-          <a:p>
-            <a:pPr lvl="2"/>
-            <a:r>
-              <a:rPr lang="en-US"/>
-              <a:t>Third level</a:t>
-            </a:r>
-          </a:p>
-          <a:p>
-            <a:pPr lvl="3"/>
-            <a:r>
-              <a:rPr lang="en-US"/>
-              <a:t>Fourth level</a:t>
-            </a:r>
-          </a:p>
-          <a:p>
-            <a:pPr lvl="4"/>
-            <a:r>
-              <a:rPr lang="en-US"/>
-              <a:t>Fifth level</a:t>
-            </a:r>
-          </a:p>
-        </p:txBody>
-      </p:sp>
-      <p:sp>
-        <p:nvSpPr>
-          <p:cNvPr id="6" name="Footer Placeholder 5"/>
-          <p:cNvSpPr>
-            <a:spLocks noGrp="1"/>
-          </p:cNvSpPr>
-          <p:nvPr>
-            <p:ph type="ftr" sz="quarter" idx="4"/>
-          </p:nvPr>
-        </p:nvSpPr>
-        <p:spPr>
-          <a:xfrm>
-            <a:off x="0" y="8685213"/>
-            <a:ext cx="2971800" cy="458787"/>
-          </a:xfrm>
-          <a:prstGeom prst="rect">
-            <a:avLst/>
-          </a:prstGeom>
-        </p:spPr>
-        <p:txBody>
-          <a:bodyPr vert="horz" lIns="91440" tIns="45720" rIns="91440" bIns="45720" rtlCol="0" anchor="b"/>
-          <a:lstStyle>
-            <a:lvl1pPr algn="l">
-              <a:defRPr sz="1200"/>
-            </a:lvl1pPr>
-          </a:lstStyle>
-          <a:p>
-            <a:endParaRPr lang="en-US"/>
-          </a:p>
-        </p:txBody>
-      </p:sp>
-      <p:sp>
-        <p:nvSpPr>
-          <p:cNvPr id="7" name="Slide Number Placeholder 6"/>
-          <p:cNvSpPr>
-            <a:spLocks noGrp="1"/>
-          </p:cNvSpPr>
-          <p:nvPr>
-            <p:ph type="sldNum" sz="quarter" idx="5"/>
-          </p:nvPr>
-        </p:nvSpPr>
-        <p:spPr>
-          <a:xfrm>
-            <a:off x="3884613" y="8685213"/>
-            <a:ext cx="2971800" cy="458787"/>
-          </a:xfrm>
-          <a:prstGeom prst="rect">
-            <a:avLst/>
-          </a:prstGeom>
-        </p:spPr>
-        <p:txBody>
-          <a:bodyPr vert="horz" lIns="91440" tIns="45720" rIns="91440" bIns="45720" rtlCol="0" anchor="b"/>
-          <a:lstStyle>
-            <a:lvl1pPr algn="r">
-              <a:defRPr sz="1200"/>
-            </a:lvl1pPr>
-          </a:lstStyle>
-          <a:p>
-            <a:fld id="{CE5E9CC1-C706-0F49-92D6-E571CC5EEA8F}" type="slidenum">
-              <a:rPr lang="en-US"/>
-              <a:t>‹#›</a:t>
-            </a:fld>
-            <a:endParaRPr lang="en-US"/>
-          </a:p>
-        </p:txBody>
-      </p:sp>
     </p:spTree>
     <p:extLst>
       <p:ext uri="{BB962C8B-B14F-4D97-AF65-F5344CB8AC3E}">
-        <p14:creationId xmlns:p14="http://schemas.microsoft.com/office/powerpoint/2010/main" val="1024086991"/>
+        <p14:creationId xmlns:p14="http://schemas.microsoft.com/office/powerpoint/2010/main" val="3256027998"/>
       </p:ext>
     </p:extLst>
   </p:cSld>
@@ -760,6 +518,13 @@
           </p:nvPr>
         </p:nvSpPr>
         <p:spPr/>
+        <p:txBody>
+          <a:bodyPr/>
+          <a:lstStyle/>
+          <a:p>
+            <a:endParaRPr lang="en-US"/>
+          </a:p>
+        </p:txBody>
       </p:sp>
       <p:sp>
         <p:nvSpPr>
@@ -776,10 +541,6 @@
           <a:bodyPr/>
           <a:lstStyle/>
           <a:p>
-            <a:r>
-              <a:rPr lang="en-US" dirty="0"/>
-              <a:t/>
-            </a:r>
             <a:endParaRPr lang="en-US" dirty="0"/>
           </a:p>
         </p:txBody>
@@ -848,6 +609,13 @@
           </p:nvPr>
         </p:nvSpPr>
         <p:spPr/>
+        <p:txBody>
+          <a:bodyPr/>
+          <a:lstStyle/>
+          <a:p>
+            <a:endParaRPr lang="en-US"/>
+          </a:p>
+        </p:txBody>
       </p:sp>
       <p:sp>
         <p:nvSpPr>
@@ -864,10 +632,6 @@
           <a:bodyPr/>
           <a:lstStyle/>
           <a:p>
-            <a:r>
-              <a:rPr lang="en-US" dirty="0"/>
-              <a:t/>
-            </a:r>
             <a:endParaRPr lang="en-US" dirty="0"/>
           </a:p>
         </p:txBody>
@@ -936,6 +700,13 @@
           </p:nvPr>
         </p:nvSpPr>
         <p:spPr/>
+        <p:txBody>
+          <a:bodyPr/>
+          <a:lstStyle/>
+          <a:p>
+            <a:endParaRPr lang="en-US"/>
+          </a:p>
+        </p:txBody>
       </p:sp>
       <p:sp>
         <p:nvSpPr>
@@ -952,10 +723,6 @@
           <a:bodyPr/>
           <a:lstStyle/>
           <a:p>
-            <a:r>
-              <a:rPr lang="en-US" dirty="0"/>
-              <a:t/>
-            </a:r>
             <a:endParaRPr lang="en-US" dirty="0"/>
           </a:p>
         </p:txBody>
@@ -1024,6 +791,13 @@
           </p:nvPr>
         </p:nvSpPr>
         <p:spPr/>
+        <p:txBody>
+          <a:bodyPr/>
+          <a:lstStyle/>
+          <a:p>
+            <a:endParaRPr lang="en-US"/>
+          </a:p>
+        </p:txBody>
       </p:sp>
       <p:sp>
         <p:nvSpPr>
@@ -1040,10 +814,6 @@
           <a:bodyPr/>
           <a:lstStyle/>
           <a:p>
-            <a:r>
-              <a:rPr lang="en-US" dirty="0"/>
-              <a:t/>
-            </a:r>
             <a:endParaRPr lang="en-US" dirty="0"/>
           </a:p>
         </p:txBody>
@@ -1112,6 +882,13 @@
           </p:nvPr>
         </p:nvSpPr>
         <p:spPr/>
+        <p:txBody>
+          <a:bodyPr/>
+          <a:lstStyle/>
+          <a:p>
+            <a:endParaRPr lang="en-US"/>
+          </a:p>
+        </p:txBody>
       </p:sp>
       <p:sp>
         <p:nvSpPr>
@@ -1128,10 +905,6 @@
           <a:bodyPr/>
           <a:lstStyle/>
           <a:p>
-            <a:r>
-              <a:rPr lang="en-US" dirty="0"/>
-              <a:t/>
-            </a:r>
             <a:endParaRPr lang="en-US" dirty="0"/>
           </a:p>
         </p:txBody>
@@ -1200,6 +973,13 @@
           </p:nvPr>
         </p:nvSpPr>
         <p:spPr/>
+        <p:txBody>
+          <a:bodyPr/>
+          <a:lstStyle/>
+          <a:p>
+            <a:endParaRPr lang="en-US"/>
+          </a:p>
+        </p:txBody>
       </p:sp>
       <p:sp>
         <p:nvSpPr>
@@ -1216,10 +996,6 @@
           <a:bodyPr/>
           <a:lstStyle/>
           <a:p>
-            <a:r>
-              <a:rPr lang="en-US" dirty="0"/>
-              <a:t/>
-            </a:r>
             <a:endParaRPr lang="en-US" dirty="0"/>
           </a:p>
         </p:txBody>
@@ -1288,6 +1064,13 @@
           </p:nvPr>
         </p:nvSpPr>
         <p:spPr/>
+        <p:txBody>
+          <a:bodyPr/>
+          <a:lstStyle/>
+          <a:p>
+            <a:endParaRPr lang="en-US"/>
+          </a:p>
+        </p:txBody>
       </p:sp>
       <p:sp>
         <p:nvSpPr>
@@ -1304,10 +1087,6 @@
           <a:bodyPr/>
           <a:lstStyle/>
           <a:p>
-            <a:r>
-              <a:rPr lang="en-US" dirty="0"/>
-              <a:t/>
-            </a:r>
             <a:endParaRPr lang="en-US" dirty="0"/>
           </a:p>
         </p:txBody>
@@ -1376,6 +1155,13 @@
           </p:nvPr>
         </p:nvSpPr>
         <p:spPr/>
+        <p:txBody>
+          <a:bodyPr/>
+          <a:lstStyle/>
+          <a:p>
+            <a:endParaRPr lang="en-US"/>
+          </a:p>
+        </p:txBody>
       </p:sp>
       <p:sp>
         <p:nvSpPr>
@@ -1392,10 +1178,6 @@
           <a:bodyPr/>
           <a:lstStyle/>
           <a:p>
-            <a:r>
-              <a:rPr lang="en-US" dirty="0"/>
-              <a:t/>
-            </a:r>
             <a:endParaRPr lang="en-US" dirty="0"/>
           </a:p>
         </p:txBody>
@@ -1464,6 +1246,13 @@
           </p:nvPr>
         </p:nvSpPr>
         <p:spPr/>
+        <p:txBody>
+          <a:bodyPr/>
+          <a:lstStyle/>
+          <a:p>
+            <a:endParaRPr lang="en-US"/>
+          </a:p>
+        </p:txBody>
       </p:sp>
       <p:sp>
         <p:nvSpPr>
@@ -1480,10 +1269,6 @@
           <a:bodyPr/>
           <a:lstStyle/>
           <a:p>
-            <a:r>
-              <a:rPr lang="en-US" dirty="0"/>
-              <a:t/>
-            </a:r>
             <a:endParaRPr lang="en-US" dirty="0"/>
           </a:p>
         </p:txBody>
@@ -1552,6 +1337,13 @@
           </p:nvPr>
         </p:nvSpPr>
         <p:spPr/>
+        <p:txBody>
+          <a:bodyPr/>
+          <a:lstStyle/>
+          <a:p>
+            <a:endParaRPr lang="en-US"/>
+          </a:p>
+        </p:txBody>
       </p:sp>
       <p:sp>
         <p:nvSpPr>
@@ -1568,10 +1360,6 @@
           <a:bodyPr/>
           <a:lstStyle/>
           <a:p>
-            <a:r>
-              <a:rPr lang="en-US" dirty="0"/>
-              <a:t/>
-            </a:r>
             <a:endParaRPr lang="en-US" dirty="0"/>
           </a:p>
         </p:txBody>
@@ -1640,6 +1428,13 @@
           </p:nvPr>
         </p:nvSpPr>
         <p:spPr/>
+        <p:txBody>
+          <a:bodyPr/>
+          <a:lstStyle/>
+          <a:p>
+            <a:endParaRPr lang="en-US"/>
+          </a:p>
+        </p:txBody>
       </p:sp>
       <p:sp>
         <p:nvSpPr>
@@ -1656,10 +1451,6 @@
           <a:bodyPr/>
           <a:lstStyle/>
           <a:p>
-            <a:r>
-              <a:rPr lang="en-US" dirty="0"/>
-              <a:t/>
-            </a:r>
             <a:endParaRPr lang="en-US" dirty="0"/>
           </a:p>
         </p:txBody>
@@ -1733,6 +1524,11 @@
 <file path=ppt/slideMasters/slideMaster1.xml><?xml version="1.0" encoding="utf-8"?>
 <p:sldMaster xmlns:a="http://schemas.openxmlformats.org/drawingml/2006/main" xmlns:r="http://schemas.openxmlformats.org/officeDocument/2006/relationships" xmlns:p="http://schemas.openxmlformats.org/presentationml/2006/main">
   <p:cSld>
+    <p:bg>
+      <p:bgRef idx="1001">
+        <a:schemeClr val="bg1"/>
+      </p:bgRef>
+    </p:bg>
     <p:spTree>
       <p:nvGrpSpPr>
         <p:cNvPr id="1" name=""/>
@@ -2015,6 +1811,7 @@
         <a:solidFill>
           <a:srgbClr val="071528"/>
         </a:solidFill>
+        <a:effectLst/>
       </p:bgPr>
     </p:bg>
     <p:spTree>
@@ -2050,6 +1847,13 @@
           </a:solidFill>
           <a:ln/>
         </p:spPr>
+        <p:txBody>
+          <a:bodyPr/>
+          <a:lstStyle/>
+          <a:p>
+            <a:endParaRPr lang="en-US"/>
+          </a:p>
+        </p:txBody>
       </p:sp>
       <p:sp>
         <p:nvSpPr>
@@ -2070,6 +1874,13 @@
           </a:solidFill>
           <a:ln/>
         </p:spPr>
+        <p:txBody>
+          <a:bodyPr/>
+          <a:lstStyle/>
+          <a:p>
+            <a:endParaRPr lang="en-US"/>
+          </a:p>
+        </p:txBody>
       </p:sp>
       <p:sp>
         <p:nvSpPr>
@@ -2092,11 +1903,11 @@
           <a:bodyPr wrap="square" lIns="0" tIns="0" rIns="0" bIns="0" rtlCol="0" anchor="ctr"/>
           <a:lstStyle/>
           <a:p>
-            <a:pPr indent="0" marL="0">
-              <a:buNone/>
-            </a:pPr>
-            <a:r>
-              <a:rPr lang="en-US" sz="1400" b="1" spc="200" kern="0" dirty="0">
+            <a:pPr marL="0" indent="0">
+              <a:buNone/>
+            </a:pPr>
+            <a:r>
+              <a:rPr lang="en-US" sz="1400" b="1" kern="0" spc="200" dirty="0">
                 <a:solidFill>
                   <a:srgbClr val="06B6D4"/>
                 </a:solidFill>
@@ -2131,7 +1942,7 @@
           <a:bodyPr wrap="square" lIns="0" tIns="0" rIns="0" bIns="0" rtlCol="0" anchor="ctr"/>
           <a:lstStyle/>
           <a:p>
-            <a:pPr indent="0" marL="0">
+            <a:pPr marL="0" indent="0">
               <a:buNone/>
             </a:pPr>
             <a:r>
@@ -2170,7 +1981,7 @@
           <a:bodyPr wrap="square" lIns="0" tIns="0" rIns="0" bIns="0" rtlCol="0" anchor="ctr"/>
           <a:lstStyle/>
           <a:p>
-            <a:pPr indent="0" marL="0">
+            <a:pPr marL="0" indent="0">
               <a:buNone/>
             </a:pPr>
             <a:r>
@@ -2210,6 +2021,13 @@
             <a:prstDash val="solid"/>
           </a:ln>
         </p:spPr>
+        <p:txBody>
+          <a:bodyPr/>
+          <a:lstStyle/>
+          <a:p>
+            <a:endParaRPr lang="en-US"/>
+          </a:p>
+        </p:txBody>
       </p:sp>
       <p:sp>
         <p:nvSpPr>
@@ -2232,7 +2050,7 @@
           <a:bodyPr wrap="square" lIns="0" tIns="0" rIns="0" bIns="0" rtlCol="0" anchor="ctr"/>
           <a:lstStyle/>
           <a:p>
-            <a:pPr indent="0" marL="0">
+            <a:pPr marL="0" indent="0">
               <a:buNone/>
             </a:pPr>
             <a:r>
@@ -2271,7 +2089,7 @@
           <a:bodyPr wrap="square" lIns="0" tIns="0" rIns="0" bIns="0" rtlCol="0" anchor="ctr"/>
           <a:lstStyle/>
           <a:p>
-            <a:pPr indent="0" marL="0">
+            <a:pPr marL="0" indent="0">
               <a:buNone/>
             </a:pPr>
             <a:r>
@@ -2283,7 +2101,7 @@
                 <a:ea typeface="Calibri" pitchFamily="34" charset="-122"/>
                 <a:cs typeface="Calibri" pitchFamily="34" charset="-120"/>
               </a:rPr>
-              <a:t>Runs entirely on your machine — no data leaves it.</a:t>
+              <a:t>Runs entirely on your machine - no data leaves it.</a:t>
             </a:r>
             <a:endParaRPr lang="en-US" sz="1500" dirty="0"/>
           </a:p>
@@ -2305,6 +2123,7 @@
         <a:solidFill>
           <a:srgbClr val="0B1E3D"/>
         </a:solidFill>
+        <a:effectLst/>
       </p:bgPr>
     </p:bg>
     <p:spTree>
@@ -2342,6 +2161,13 @@
           </a:solidFill>
           <a:ln/>
         </p:spPr>
+        <p:txBody>
+          <a:bodyPr/>
+          <a:lstStyle/>
+          <a:p>
+            <a:endParaRPr lang="en-US"/>
+          </a:p>
+        </p:txBody>
       </p:sp>
       <p:sp>
         <p:nvSpPr>
@@ -2364,7 +2190,7 @@
           <a:bodyPr wrap="square" lIns="0" tIns="0" rIns="0" bIns="0" rtlCol="0" anchor="ctr"/>
           <a:lstStyle/>
           <a:p>
-            <a:pPr algn="ctr" indent="0" marL="0">
+            <a:pPr marL="0" indent="0" algn="ctr">
               <a:buNone/>
             </a:pPr>
             <a:r>
@@ -2376,7 +2202,7 @@
                 <a:ea typeface="Calibri" pitchFamily="34" charset="-122"/>
                 <a:cs typeface="Calibri" pitchFamily="34" charset="-120"/>
               </a:rPr>
-              <a:t>Limitations [5]  ·  Future [5]</a:t>
+              <a:t>Limitations  ·  Future</a:t>
             </a:r>
             <a:endParaRPr lang="en-US" sz="1200" dirty="0"/>
           </a:p>
@@ -2403,7 +2229,7 @@
           <a:bodyPr wrap="square" lIns="0" tIns="0" rIns="0" bIns="0" rtlCol="0" anchor="ctr"/>
           <a:lstStyle/>
           <a:p>
-            <a:pPr indent="0" marL="0">
+            <a:pPr marL="0" indent="0">
               <a:buNone/>
             </a:pPr>
             <a:r>
@@ -2447,13 +2273,20 @@
             <a:prstDash val="solid"/>
           </a:ln>
           <a:effectLst>
-            <a:outerShdw sx="100000" sy="100000" kx="0" ky="0" algn="bl" rotWithShape="0" blurRad="101600" dist="38100" dir="5400000">
+            <a:outerShdw blurRad="101600" dist="38100" dir="5400000" algn="bl" rotWithShape="0">
               <a:srgbClr val="071018">
                 <a:alpha val="45000"/>
               </a:srgbClr>
             </a:outerShdw>
           </a:effectLst>
         </p:spPr>
+        <p:txBody>
+          <a:bodyPr/>
+          <a:lstStyle/>
+          <a:p>
+            <a:endParaRPr lang="en-US"/>
+          </a:p>
+        </p:txBody>
       </p:sp>
       <p:sp>
         <p:nvSpPr>
@@ -2476,11 +2309,11 @@
           <a:bodyPr wrap="square" lIns="0" tIns="0" rIns="0" bIns="0" rtlCol="0" anchor="ctr"/>
           <a:lstStyle/>
           <a:p>
-            <a:pPr indent="0" marL="0">
-              <a:buNone/>
-            </a:pPr>
-            <a:r>
-              <a:rPr lang="en-US" sz="1400" b="1" spc="200" kern="0" dirty="0">
+            <a:pPr marL="0" indent="0">
+              <a:buNone/>
+            </a:pPr>
+            <a:r>
+              <a:rPr lang="en-US" sz="1400" b="1" kern="0" spc="200" dirty="0">
                 <a:solidFill>
                   <a:srgbClr val="F59E0B"/>
                 </a:solidFill>
@@ -2502,8 +2335,8 @@
         </p:nvSpPr>
         <p:spPr>
           <a:xfrm>
-            <a:off x="914400" y="2651760"/>
-            <a:ext cx="4754880" cy="2560320"/>
+            <a:off x="914399" y="2651760"/>
+            <a:ext cx="4933741" cy="2560320"/>
           </a:xfrm>
           <a:prstGeom prst="rect">
             <a:avLst/>
@@ -2573,7 +2406,7 @@
                 <a:ea typeface="Calibri" pitchFamily="34" charset="-122"/>
                 <a:cs typeface="Calibri" pitchFamily="34" charset="-120"/>
               </a:rPr>
-              <a:t>Small evaluation set — single-item flips are noise</a:t>
+              <a:t>Small evaluation set - single-item flips are noise</a:t>
             </a:r>
             <a:endParaRPr lang="en-US" sz="1500" dirty="0"/>
           </a:p>
@@ -2626,13 +2459,20 @@
             <a:prstDash val="solid"/>
           </a:ln>
           <a:effectLst>
-            <a:outerShdw sx="100000" sy="100000" kx="0" ky="0" algn="bl" rotWithShape="0" blurRad="101600" dist="38100" dir="5400000">
+            <a:outerShdw blurRad="101600" dist="38100" dir="5400000" algn="bl" rotWithShape="0">
               <a:srgbClr val="071018">
                 <a:alpha val="45000"/>
               </a:srgbClr>
             </a:outerShdw>
           </a:effectLst>
         </p:spPr>
+        <p:txBody>
+          <a:bodyPr/>
+          <a:lstStyle/>
+          <a:p>
+            <a:endParaRPr lang="en-US"/>
+          </a:p>
+        </p:txBody>
       </p:sp>
       <p:sp>
         <p:nvSpPr>
@@ -2655,11 +2495,11 @@
           <a:bodyPr wrap="square" lIns="0" tIns="0" rIns="0" bIns="0" rtlCol="0" anchor="ctr"/>
           <a:lstStyle/>
           <a:p>
-            <a:pPr indent="0" marL="0">
-              <a:buNone/>
-            </a:pPr>
-            <a:r>
-              <a:rPr lang="en-US" sz="1400" b="1" spc="200" kern="0" dirty="0">
+            <a:pPr marL="0" indent="0">
+              <a:buNone/>
+            </a:pPr>
+            <a:r>
+              <a:rPr lang="en-US" sz="1400" b="1" kern="0" spc="200" dirty="0">
                 <a:solidFill>
                   <a:srgbClr val="06B6D4"/>
                 </a:solidFill>
@@ -2795,6 +2635,7 @@
         <a:solidFill>
           <a:srgbClr val="071528"/>
         </a:solidFill>
+        <a:effectLst/>
       </p:bgPr>
     </p:bg>
     <p:spTree>
@@ -2830,6 +2671,13 @@
           </a:solidFill>
           <a:ln/>
         </p:spPr>
+        <p:txBody>
+          <a:bodyPr/>
+          <a:lstStyle/>
+          <a:p>
+            <a:endParaRPr lang="en-US"/>
+          </a:p>
+        </p:txBody>
       </p:sp>
       <p:sp>
         <p:nvSpPr>
@@ -2852,7 +2700,7 @@
           <a:bodyPr wrap="square" lIns="0" tIns="0" rIns="0" bIns="0" rtlCol="0" anchor="ctr"/>
           <a:lstStyle/>
           <a:p>
-            <a:pPr indent="0" marL="0">
+            <a:pPr marL="0" indent="0">
               <a:buNone/>
             </a:pPr>
             <a:r>
@@ -2891,7 +2739,7 @@
           <a:bodyPr wrap="square" lIns="0" tIns="0" rIns="0" bIns="0" rtlCol="0" anchor="ctr"/>
           <a:lstStyle/>
           <a:p>
-            <a:pPr indent="0" marL="0">
+            <a:pPr marL="0" indent="0">
               <a:buNone/>
             </a:pPr>
             <a:r>
@@ -2903,7 +2751,7 @@
                 <a:ea typeface="Calibri" pitchFamily="34" charset="-122"/>
                 <a:cs typeface="Calibri" pitchFamily="34" charset="-120"/>
               </a:rPr>
-              <a:t>A capable AI assistant for quantum-oncology — running entirely on your machine.</a:t>
+              <a:t>A capable AI assistant for quantum-oncology - running entirely on your machine.</a:t>
             </a:r>
             <a:endParaRPr lang="en-US" sz="1900" dirty="0"/>
           </a:p>
@@ -2931,6 +2779,13 @@
             <a:prstDash val="solid"/>
           </a:ln>
         </p:spPr>
+        <p:txBody>
+          <a:bodyPr/>
+          <a:lstStyle/>
+          <a:p>
+            <a:endParaRPr lang="en-US"/>
+          </a:p>
+        </p:txBody>
       </p:sp>
       <p:sp>
         <p:nvSpPr>
@@ -2953,7 +2808,7 @@
           <a:bodyPr wrap="square" lIns="0" tIns="0" rIns="0" bIns="0" rtlCol="0" anchor="ctr"/>
           <a:lstStyle/>
           <a:p>
-            <a:pPr indent="0" marL="0">
+            <a:pPr marL="0" indent="0">
               <a:buNone/>
             </a:pPr>
             <a:r>
@@ -2992,7 +2847,7 @@
           <a:bodyPr wrap="square" lIns="0" tIns="0" rIns="0" bIns="0" rtlCol="0" anchor="ctr"/>
           <a:lstStyle/>
           <a:p>
-            <a:pPr indent="0" marL="0">
+            <a:pPr marL="0" indent="0">
               <a:buNone/>
             </a:pPr>
             <a:r>
@@ -3031,7 +2886,7 @@
           <a:bodyPr wrap="square" lIns="0" tIns="0" rIns="0" bIns="0" rtlCol="0" anchor="ctr"/>
           <a:lstStyle/>
           <a:p>
-            <a:pPr indent="0" marL="0">
+            <a:pPr marL="0" indent="0">
               <a:buNone/>
             </a:pPr>
             <a:r>
@@ -3065,6 +2920,7 @@
         <a:solidFill>
           <a:srgbClr val="0B1E3D"/>
         </a:solidFill>
+        <a:effectLst/>
       </p:bgPr>
     </p:bg>
     <p:spTree>
@@ -3102,6 +2958,13 @@
           </a:solidFill>
           <a:ln/>
         </p:spPr>
+        <p:txBody>
+          <a:bodyPr/>
+          <a:lstStyle/>
+          <a:p>
+            <a:endParaRPr lang="en-US"/>
+          </a:p>
+        </p:txBody>
       </p:sp>
       <p:sp>
         <p:nvSpPr>
@@ -3124,7 +2987,7 @@
           <a:bodyPr wrap="square" lIns="0" tIns="0" rIns="0" bIns="0" rtlCol="0" anchor="ctr"/>
           <a:lstStyle/>
           <a:p>
-            <a:pPr algn="ctr" indent="0" marL="0">
+            <a:pPr marL="0" indent="0" algn="ctr">
               <a:buNone/>
             </a:pPr>
             <a:r>
@@ -3163,7 +3026,7 @@
           <a:bodyPr wrap="square" lIns="0" tIns="0" rIns="0" bIns="0" rtlCol="0" anchor="ctr"/>
           <a:lstStyle/>
           <a:p>
-            <a:pPr indent="0" marL="0">
+            <a:pPr marL="0" indent="0">
               <a:buNone/>
             </a:pPr>
             <a:r>
@@ -3207,13 +3070,20 @@
             <a:prstDash val="solid"/>
           </a:ln>
           <a:effectLst>
-            <a:outerShdw sx="100000" sy="100000" kx="0" ky="0" algn="bl" rotWithShape="0" blurRad="101600" dist="38100" dir="5400000">
+            <a:outerShdw blurRad="101600" dist="38100" dir="5400000" algn="bl" rotWithShape="0">
               <a:srgbClr val="071018">
                 <a:alpha val="45000"/>
               </a:srgbClr>
             </a:outerShdw>
           </a:effectLst>
         </p:spPr>
+        <p:txBody>
+          <a:bodyPr/>
+          <a:lstStyle/>
+          <a:p>
+            <a:endParaRPr lang="en-US"/>
+          </a:p>
+        </p:txBody>
       </p:sp>
       <p:sp>
         <p:nvSpPr>
@@ -3234,6 +3104,13 @@
           </a:solidFill>
           <a:ln/>
         </p:spPr>
+        <p:txBody>
+          <a:bodyPr/>
+          <a:lstStyle/>
+          <a:p>
+            <a:endParaRPr lang="en-US"/>
+          </a:p>
+        </p:txBody>
       </p:sp>
       <p:sp>
         <p:nvSpPr>
@@ -3256,7 +3133,7 @@
           <a:bodyPr wrap="square" lIns="0" tIns="0" rIns="0" bIns="0" rtlCol="0" anchor="ctr"/>
           <a:lstStyle/>
           <a:p>
-            <a:pPr algn="ctr" indent="0" marL="0">
+            <a:pPr marL="0" indent="0" algn="ctr">
               <a:buNone/>
             </a:pPr>
             <a:r>
@@ -3295,7 +3172,7 @@
           <a:bodyPr wrap="square" lIns="0" tIns="0" rIns="0" bIns="0" rtlCol="0" anchor="ctr"/>
           <a:lstStyle/>
           <a:p>
-            <a:pPr indent="0" marL="0">
+            <a:pPr marL="0" indent="0">
               <a:buNone/>
             </a:pPr>
             <a:r>
@@ -3334,7 +3211,7 @@
           <a:bodyPr wrap="square" lIns="0" tIns="0" rIns="0" bIns="0" rtlCol="0" anchor="ctr"/>
           <a:lstStyle/>
           <a:p>
-            <a:pPr indent="0" marL="0">
+            <a:pPr marL="0" indent="0">
               <a:buNone/>
             </a:pPr>
             <a:r>
@@ -3346,7 +3223,7 @@
                 <a:ea typeface="Calibri" pitchFamily="34" charset="-122"/>
                 <a:cs typeface="Calibri" pitchFamily="34" charset="-120"/>
               </a:rPr>
-              <a:t>Nine-part provenance records, quantum energies in Hartree, and cryptographic seals — hard to read and review.</a:t>
+              <a:t>Nine-part provenance records, quantum energies in Hartree, and cryptographic seals - hard to read and review.</a:t>
             </a:r>
             <a:endParaRPr lang="en-US" sz="1500" dirty="0"/>
           </a:p>
@@ -3378,13 +3255,20 @@
             <a:prstDash val="solid"/>
           </a:ln>
           <a:effectLst>
-            <a:outerShdw sx="100000" sy="100000" kx="0" ky="0" algn="bl" rotWithShape="0" blurRad="101600" dist="38100" dir="5400000">
+            <a:outerShdw blurRad="101600" dist="38100" dir="5400000" algn="bl" rotWithShape="0">
               <a:srgbClr val="071018">
                 <a:alpha val="45000"/>
               </a:srgbClr>
             </a:outerShdw>
           </a:effectLst>
         </p:spPr>
+        <p:txBody>
+          <a:bodyPr/>
+          <a:lstStyle/>
+          <a:p>
+            <a:endParaRPr lang="en-US"/>
+          </a:p>
+        </p:txBody>
       </p:sp>
       <p:sp>
         <p:nvSpPr>
@@ -3405,6 +3289,13 @@
           </a:solidFill>
           <a:ln/>
         </p:spPr>
+        <p:txBody>
+          <a:bodyPr/>
+          <a:lstStyle/>
+          <a:p>
+            <a:endParaRPr lang="en-US"/>
+          </a:p>
+        </p:txBody>
       </p:sp>
       <p:sp>
         <p:nvSpPr>
@@ -3427,7 +3318,7 @@
           <a:bodyPr wrap="square" lIns="0" tIns="0" rIns="0" bIns="0" rtlCol="0" anchor="ctr"/>
           <a:lstStyle/>
           <a:p>
-            <a:pPr algn="ctr" indent="0" marL="0">
+            <a:pPr marL="0" indent="0" algn="ctr">
               <a:buNone/>
             </a:pPr>
             <a:r>
@@ -3466,7 +3357,7 @@
           <a:bodyPr wrap="square" lIns="0" tIns="0" rIns="0" bIns="0" rtlCol="0" anchor="ctr"/>
           <a:lstStyle/>
           <a:p>
-            <a:pPr indent="0" marL="0">
+            <a:pPr marL="0" indent="0">
               <a:buNone/>
             </a:pPr>
             <a:r>
@@ -3505,7 +3396,7 @@
           <a:bodyPr wrap="square" lIns="0" tIns="0" rIns="0" bIns="0" rtlCol="0" anchor="ctr"/>
           <a:lstStyle/>
           <a:p>
-            <a:pPr indent="0" marL="0">
+            <a:pPr marL="0" indent="0">
               <a:buNone/>
             </a:pPr>
             <a:r>
@@ -3549,13 +3440,20 @@
             <a:prstDash val="solid"/>
           </a:ln>
           <a:effectLst>
-            <a:outerShdw sx="100000" sy="100000" kx="0" ky="0" algn="bl" rotWithShape="0" blurRad="101600" dist="38100" dir="5400000">
+            <a:outerShdw blurRad="101600" dist="38100" dir="5400000" algn="bl" rotWithShape="0">
               <a:srgbClr val="071018">
                 <a:alpha val="45000"/>
               </a:srgbClr>
             </a:outerShdw>
           </a:effectLst>
         </p:spPr>
+        <p:txBody>
+          <a:bodyPr/>
+          <a:lstStyle/>
+          <a:p>
+            <a:endParaRPr lang="en-US"/>
+          </a:p>
+        </p:txBody>
       </p:sp>
       <p:sp>
         <p:nvSpPr>
@@ -3576,6 +3474,13 @@
           </a:solidFill>
           <a:ln/>
         </p:spPr>
+        <p:txBody>
+          <a:bodyPr/>
+          <a:lstStyle/>
+          <a:p>
+            <a:endParaRPr lang="en-US"/>
+          </a:p>
+        </p:txBody>
       </p:sp>
       <p:sp>
         <p:nvSpPr>
@@ -3598,7 +3503,7 @@
           <a:bodyPr wrap="square" lIns="0" tIns="0" rIns="0" bIns="0" rtlCol="0" anchor="ctr"/>
           <a:lstStyle/>
           <a:p>
-            <a:pPr algn="ctr" indent="0" marL="0">
+            <a:pPr marL="0" indent="0" algn="ctr">
               <a:buNone/>
             </a:pPr>
             <a:r>
@@ -3637,7 +3542,7 @@
           <a:bodyPr wrap="square" lIns="0" tIns="0" rIns="0" bIns="0" rtlCol="0" anchor="ctr"/>
           <a:lstStyle/>
           <a:p>
-            <a:pPr indent="0" marL="0">
+            <a:pPr marL="0" indent="0">
               <a:buNone/>
             </a:pPr>
             <a:r>
@@ -3676,7 +3581,7 @@
           <a:bodyPr wrap="square" lIns="0" tIns="0" rIns="0" bIns="0" rtlCol="0" anchor="ctr"/>
           <a:lstStyle/>
           <a:p>
-            <a:pPr indent="0" marL="0">
+            <a:pPr marL="0" indent="0">
               <a:buNone/>
             </a:pPr>
             <a:r>
@@ -3710,6 +3615,7 @@
         <a:solidFill>
           <a:srgbClr val="0B1E3D"/>
         </a:solidFill>
+        <a:effectLst/>
       </p:bgPr>
     </p:bg>
     <p:spTree>
@@ -3747,6 +3653,13 @@
           </a:solidFill>
           <a:ln/>
         </p:spPr>
+        <p:txBody>
+          <a:bodyPr/>
+          <a:lstStyle/>
+          <a:p>
+            <a:endParaRPr lang="en-US"/>
+          </a:p>
+        </p:txBody>
       </p:sp>
       <p:sp>
         <p:nvSpPr>
@@ -3769,7 +3682,7 @@
           <a:bodyPr wrap="square" lIns="0" tIns="0" rIns="0" bIns="0" rtlCol="0" anchor="ctr"/>
           <a:lstStyle/>
           <a:p>
-            <a:pPr algn="ctr" indent="0" marL="0">
+            <a:pPr marL="0" indent="0" algn="ctr">
               <a:buNone/>
             </a:pPr>
             <a:r>
@@ -3808,7 +3721,7 @@
           <a:bodyPr wrap="square" lIns="0" tIns="0" rIns="0" bIns="0" rtlCol="0" anchor="ctr"/>
           <a:lstStyle/>
           <a:p>
-            <a:pPr indent="0" marL="0">
+            <a:pPr marL="0" indent="0">
               <a:buNone/>
             </a:pPr>
             <a:r>
@@ -3820,7 +3733,7 @@
                 <a:ea typeface="Cambria" pitchFamily="34" charset="-122"/>
                 <a:cs typeface="Cambria" pitchFamily="34" charset="-120"/>
               </a:rPr>
-              <a:t>Capable AI — running privately, on a laptop</a:t>
+              <a:t>Capable AI - running privately, on a laptop</a:t>
             </a:r>
             <a:endParaRPr lang="en-US" sz="3400" dirty="0"/>
           </a:p>
@@ -3863,7 +3776,7 @@
                 <a:ea typeface="Calibri" pitchFamily="34" charset="-122"/>
                 <a:cs typeface="Calibri" pitchFamily="34" charset="-120"/>
               </a:rPr>
-              <a:t>Small local models are now good enough to extract, summarize, and answer over scientific records — no cloud.</a:t>
+              <a:t>Small local models are now good enough to extract, summarize, and answer over scientific records - no cloud.</a:t>
             </a:r>
             <a:endParaRPr lang="en-US" sz="1700" dirty="0"/>
           </a:p>
@@ -3884,9 +3797,8 @@
                 <a:ea typeface="Calibri" pitchFamily="34" charset="-122"/>
                 <a:cs typeface="Calibri" pitchFamily="34" charset="-120"/>
               </a:rPr>
-              <a:t>Served locally via Ollama; nothing ever leaves the machine (a benefit a cloud API cannot offer).</a:t>
-            </a:r>
-            <a:endParaRPr lang="en-US" sz="1700" dirty="0"/>
+              <a:t>Served locally via Ollama. nothing ever leaves the machine.      (a benefit a cloud API cannot offer) </a:t>
+            </a:r>
           </a:p>
           <a:p>
             <a:pPr marL="228600" indent="-228600">
@@ -3905,7 +3817,7 @@
                 <a:ea typeface="Calibri" pitchFamily="34" charset="-122"/>
                 <a:cs typeface="Calibri" pitchFamily="34" charset="-120"/>
               </a:rPr>
-              <a:t>Every answer is grounded in retrieved sources and cites them — it refuses rather than guessing.</a:t>
+              <a:t>Every answer is grounded in retrieved sources and cites them - it refuses rather than guessing.</a:t>
             </a:r>
             <a:endParaRPr lang="en-US" sz="1700" dirty="0"/>
           </a:p>
@@ -3937,13 +3849,20 @@
             <a:prstDash val="solid"/>
           </a:ln>
           <a:effectLst>
-            <a:outerShdw sx="100000" sy="100000" kx="0" ky="0" algn="bl" rotWithShape="0" blurRad="101600" dist="38100" dir="5400000">
+            <a:outerShdw blurRad="101600" dist="38100" dir="5400000" algn="bl" rotWithShape="0">
               <a:srgbClr val="071018">
                 <a:alpha val="45000"/>
               </a:srgbClr>
             </a:outerShdw>
           </a:effectLst>
         </p:spPr>
+        <p:txBody>
+          <a:bodyPr/>
+          <a:lstStyle/>
+          <a:p>
+            <a:endParaRPr lang="en-US"/>
+          </a:p>
+        </p:txBody>
       </p:sp>
       <p:sp>
         <p:nvSpPr>
@@ -3966,11 +3885,11 @@
           <a:bodyPr wrap="square" lIns="0" tIns="0" rIns="0" bIns="0" rtlCol="0" anchor="ctr"/>
           <a:lstStyle/>
           <a:p>
-            <a:pPr indent="0" marL="0">
-              <a:buNone/>
-            </a:pPr>
-            <a:r>
-              <a:rPr lang="en-US" sz="1300" b="1" spc="200" kern="0" dirty="0">
+            <a:pPr marL="0" indent="0">
+              <a:buNone/>
+            </a:pPr>
+            <a:r>
+              <a:rPr lang="en-US" sz="1300" b="1" kern="0" spc="200" dirty="0">
                 <a:solidFill>
                   <a:srgbClr val="06B6D4"/>
                 </a:solidFill>
@@ -4005,7 +3924,7 @@
           <a:bodyPr wrap="square" lIns="0" tIns="0" rIns="0" bIns="0" rtlCol="0" anchor="ctr"/>
           <a:lstStyle/>
           <a:p>
-            <a:pPr indent="0" marL="0">
+            <a:pPr marL="0" indent="0">
               <a:lnSpc>
                 <a:spcPct val="105000"/>
               </a:lnSpc>
@@ -4025,7 +3944,7 @@
             <a:endParaRPr lang="en-US" sz="2200" dirty="0"/>
           </a:p>
           <a:p>
-            <a:pPr indent="0" marL="0">
+            <a:pPr marL="0" indent="0">
               <a:lnSpc>
                 <a:spcPct val="105000"/>
               </a:lnSpc>
@@ -4067,7 +3986,7 @@
           <a:bodyPr wrap="square" lIns="0" tIns="0" rIns="0" bIns="0" rtlCol="0" anchor="ctr"/>
           <a:lstStyle/>
           <a:p>
-            <a:pPr indent="0" marL="0">
+            <a:pPr marL="0" indent="0">
               <a:buNone/>
             </a:pPr>
             <a:r>
@@ -4079,7 +3998,7 @@
                 <a:ea typeface="Calibri" pitchFamily="34" charset="-122"/>
                 <a:cs typeface="Calibri" pitchFamily="34" charset="-120"/>
               </a:rPr>
-              <a:t>Remove randomness at the LLM layer (temperature 0); notarize it where it is physical — quantum sampling — with cryptographic seals. Grounding handles correctness.</a:t>
+              <a:t>Remove randomness at the LLM layer (temperature 0). notarize it where it is physical - quantum sampling - with cryptographic seals. Grounding handles correctness.</a:t>
             </a:r>
             <a:endParaRPr lang="en-US" sz="1400" dirty="0"/>
           </a:p>
@@ -4101,6 +4020,7 @@
         <a:solidFill>
           <a:srgbClr val="0B1E3D"/>
         </a:solidFill>
+        <a:effectLst/>
       </p:bgPr>
     </p:bg>
     <p:spTree>
@@ -4138,6 +4058,13 @@
           </a:solidFill>
           <a:ln/>
         </p:spPr>
+        <p:txBody>
+          <a:bodyPr/>
+          <a:lstStyle/>
+          <a:p>
+            <a:endParaRPr lang="en-US"/>
+          </a:p>
+        </p:txBody>
       </p:sp>
       <p:sp>
         <p:nvSpPr>
@@ -4160,7 +4087,7 @@
           <a:bodyPr wrap="square" lIns="0" tIns="0" rIns="0" bIns="0" rtlCol="0" anchor="ctr"/>
           <a:lstStyle/>
           <a:p>
-            <a:pPr algn="ctr" indent="0" marL="0">
+            <a:pPr marL="0" indent="0" algn="ctr">
               <a:buNone/>
             </a:pPr>
             <a:r>
@@ -4172,7 +4099,7 @@
                 <a:ea typeface="Calibri" pitchFamily="34" charset="-122"/>
                 <a:cs typeface="Calibri" pitchFamily="34" charset="-120"/>
               </a:rPr>
-              <a:t>Model choice  [5 pts]</a:t>
+              <a:t>Model choice  </a:t>
             </a:r>
             <a:endParaRPr lang="en-US" sz="1200" dirty="0"/>
           </a:p>
@@ -4199,7 +4126,7 @@
           <a:bodyPr wrap="square" lIns="0" tIns="0" rIns="0" bIns="0" rtlCol="0" anchor="ctr"/>
           <a:lstStyle/>
           <a:p>
-            <a:pPr indent="0" marL="0">
+            <a:pPr marL="0" indent="0">
               <a:buNone/>
             </a:pPr>
             <a:r>
@@ -4243,13 +4170,20 @@
             <a:prstDash val="solid"/>
           </a:ln>
           <a:effectLst>
-            <a:outerShdw sx="100000" sy="100000" kx="0" ky="0" algn="bl" rotWithShape="0" blurRad="101600" dist="38100" dir="5400000">
+            <a:outerShdw blurRad="101600" dist="38100" dir="5400000" algn="bl" rotWithShape="0">
               <a:srgbClr val="071018">
                 <a:alpha val="45000"/>
               </a:srgbClr>
             </a:outerShdw>
           </a:effectLst>
         </p:spPr>
+        <p:txBody>
+          <a:bodyPr/>
+          <a:lstStyle/>
+          <a:p>
+            <a:endParaRPr lang="en-US"/>
+          </a:p>
+        </p:txBody>
       </p:sp>
       <p:sp>
         <p:nvSpPr>
@@ -4272,7 +4206,7 @@
           <a:bodyPr wrap="square" lIns="0" tIns="0" rIns="0" bIns="0" rtlCol="0" anchor="ctr"/>
           <a:lstStyle/>
           <a:p>
-            <a:pPr indent="0" marL="0">
+            <a:pPr marL="0" indent="0">
               <a:buNone/>
             </a:pPr>
             <a:r>
@@ -4311,7 +4245,7 @@
           <a:bodyPr wrap="square" lIns="0" tIns="0" rIns="0" bIns="0" rtlCol="0" anchor="ctr"/>
           <a:lstStyle/>
           <a:p>
-            <a:pPr indent="0" marL="0">
+            <a:pPr marL="0" indent="0">
               <a:buNone/>
             </a:pPr>
             <a:r>
@@ -4350,7 +4284,7 @@
           <a:bodyPr wrap="square" lIns="0" tIns="0" rIns="0" bIns="0" rtlCol="0" anchor="ctr"/>
           <a:lstStyle/>
           <a:p>
-            <a:pPr indent="0" marL="0">
+            <a:pPr marL="0" indent="0">
               <a:buNone/>
             </a:pPr>
             <a:r>
@@ -4394,13 +4328,20 @@
             <a:prstDash val="solid"/>
           </a:ln>
           <a:effectLst>
-            <a:outerShdw sx="100000" sy="100000" kx="0" ky="0" algn="bl" rotWithShape="0" blurRad="101600" dist="38100" dir="5400000">
+            <a:outerShdw blurRad="101600" dist="38100" dir="5400000" algn="bl" rotWithShape="0">
               <a:srgbClr val="071018">
                 <a:alpha val="45000"/>
               </a:srgbClr>
             </a:outerShdw>
           </a:effectLst>
         </p:spPr>
+        <p:txBody>
+          <a:bodyPr/>
+          <a:lstStyle/>
+          <a:p>
+            <a:endParaRPr lang="en-US"/>
+          </a:p>
+        </p:txBody>
       </p:sp>
       <p:sp>
         <p:nvSpPr>
@@ -4423,7 +4364,7 @@
           <a:bodyPr wrap="square" lIns="0" tIns="0" rIns="0" bIns="0" rtlCol="0" anchor="ctr"/>
           <a:lstStyle/>
           <a:p>
-            <a:pPr indent="0" marL="0">
+            <a:pPr marL="0" indent="0">
               <a:buNone/>
             </a:pPr>
             <a:r>
@@ -4462,7 +4403,7 @@
           <a:bodyPr wrap="square" lIns="0" tIns="0" rIns="0" bIns="0" rtlCol="0" anchor="ctr"/>
           <a:lstStyle/>
           <a:p>
-            <a:pPr indent="0" marL="0">
+            <a:pPr marL="0" indent="0">
               <a:buNone/>
             </a:pPr>
             <a:r>
@@ -4501,7 +4442,7 @@
           <a:bodyPr wrap="square" lIns="0" tIns="0" rIns="0" bIns="0" rtlCol="0" anchor="ctr"/>
           <a:lstStyle/>
           <a:p>
-            <a:pPr indent="0" marL="0">
+            <a:pPr marL="0" indent="0">
               <a:buNone/>
             </a:pPr>
             <a:r>
@@ -4545,13 +4486,20 @@
             <a:prstDash val="solid"/>
           </a:ln>
           <a:effectLst>
-            <a:outerShdw sx="100000" sy="100000" kx="0" ky="0" algn="bl" rotWithShape="0" blurRad="101600" dist="38100" dir="5400000">
+            <a:outerShdw blurRad="101600" dist="38100" dir="5400000" algn="bl" rotWithShape="0">
               <a:srgbClr val="071018">
                 <a:alpha val="45000"/>
               </a:srgbClr>
             </a:outerShdw>
           </a:effectLst>
         </p:spPr>
+        <p:txBody>
+          <a:bodyPr/>
+          <a:lstStyle/>
+          <a:p>
+            <a:endParaRPr lang="en-US"/>
+          </a:p>
+        </p:txBody>
       </p:sp>
       <p:sp>
         <p:nvSpPr>
@@ -4576,6 +4524,13 @@
             <a:prstDash val="solid"/>
           </a:ln>
         </p:spPr>
+        <p:txBody>
+          <a:bodyPr/>
+          <a:lstStyle/>
+          <a:p>
+            <a:endParaRPr lang="en-US"/>
+          </a:p>
+        </p:txBody>
       </p:sp>
       <p:sp>
         <p:nvSpPr>
@@ -4598,7 +4553,7 @@
           <a:bodyPr wrap="square" lIns="0" tIns="0" rIns="0" bIns="0" rtlCol="0" anchor="ctr"/>
           <a:lstStyle/>
           <a:p>
-            <a:pPr indent="0" marL="0">
+            <a:pPr marL="0" indent="0">
               <a:buNone/>
             </a:pPr>
             <a:r>
@@ -4637,7 +4592,7 @@
           <a:bodyPr wrap="square" lIns="0" tIns="0" rIns="0" bIns="0" rtlCol="0" anchor="ctr"/>
           <a:lstStyle/>
           <a:p>
-            <a:pPr indent="0" marL="0">
+            <a:pPr marL="0" indent="0">
               <a:buNone/>
             </a:pPr>
             <a:r>
@@ -4676,7 +4631,7 @@
           <a:bodyPr wrap="square" lIns="0" tIns="0" rIns="0" bIns="0" rtlCol="0" anchor="ctr"/>
           <a:lstStyle/>
           <a:p>
-            <a:pPr indent="0" marL="0">
+            <a:pPr marL="0" indent="0">
               <a:buNone/>
             </a:pPr>
             <a:r>
@@ -4688,7 +4643,7 @@
                 <a:ea typeface="Calibri" pitchFamily="34" charset="-122"/>
                 <a:cs typeface="Calibri" pitchFamily="34" charset="-120"/>
               </a:rPr>
-              <a:t>general — our pick</a:t>
+              <a:t>general - our pick</a:t>
             </a:r>
             <a:endParaRPr lang="en-US" sz="1400" dirty="0"/>
           </a:p>
@@ -4715,6 +4670,13 @@
           </a:solidFill>
           <a:ln/>
         </p:spPr>
+        <p:txBody>
+          <a:bodyPr/>
+          <a:lstStyle/>
+          <a:p>
+            <a:endParaRPr lang="en-US"/>
+          </a:p>
+        </p:txBody>
       </p:sp>
       <p:sp>
         <p:nvSpPr>
@@ -4737,7 +4699,7 @@
           <a:bodyPr wrap="square" lIns="0" tIns="0" rIns="0" bIns="0" rtlCol="0" anchor="ctr"/>
           <a:lstStyle/>
           <a:p>
-            <a:pPr algn="ctr" indent="0" marL="0">
+            <a:pPr marL="0" indent="0" algn="ctr">
               <a:buNone/>
             </a:pPr>
             <a:r>
@@ -4781,13 +4743,20 @@
             <a:prstDash val="solid"/>
           </a:ln>
           <a:effectLst>
-            <a:outerShdw sx="100000" sy="100000" kx="0" ky="0" algn="bl" rotWithShape="0" blurRad="101600" dist="38100" dir="5400000">
+            <a:outerShdw blurRad="101600" dist="38100" dir="5400000" algn="bl" rotWithShape="0">
               <a:srgbClr val="071018">
                 <a:alpha val="45000"/>
               </a:srgbClr>
             </a:outerShdw>
           </a:effectLst>
         </p:spPr>
+        <p:txBody>
+          <a:bodyPr/>
+          <a:lstStyle/>
+          <a:p>
+            <a:endParaRPr lang="en-US"/>
+          </a:p>
+        </p:txBody>
       </p:sp>
       <p:sp>
         <p:nvSpPr>
@@ -4810,7 +4779,7 @@
           <a:bodyPr wrap="square" lIns="0" tIns="0" rIns="0" bIns="0" rtlCol="0" anchor="ctr"/>
           <a:lstStyle/>
           <a:p>
-            <a:pPr indent="0" marL="0">
+            <a:pPr marL="0" indent="0">
               <a:buNone/>
             </a:pPr>
             <a:r>
@@ -4849,7 +4818,7 @@
           <a:bodyPr wrap="square" lIns="0" tIns="0" rIns="0" bIns="0" rtlCol="0" anchor="ctr"/>
           <a:lstStyle/>
           <a:p>
-            <a:pPr indent="0" marL="0">
+            <a:pPr marL="0" indent="0">
               <a:buNone/>
             </a:pPr>
             <a:r>
@@ -4888,7 +4857,7 @@
           <a:bodyPr wrap="square" lIns="0" tIns="0" rIns="0" bIns="0" rtlCol="0" anchor="ctr"/>
           <a:lstStyle/>
           <a:p>
-            <a:pPr indent="0" marL="0">
+            <a:pPr marL="0" indent="0">
               <a:buNone/>
             </a:pPr>
             <a:r>
@@ -4927,7 +4896,7 @@
           <a:bodyPr wrap="square" lIns="0" tIns="0" rIns="0" bIns="0" rtlCol="0" anchor="ctr"/>
           <a:lstStyle/>
           <a:p>
-            <a:pPr indent="0" marL="0">
+            <a:pPr marL="0" indent="0">
               <a:buNone/>
             </a:pPr>
             <a:r>
@@ -4939,7 +4908,7 @@
                 <a:ea typeface="Calibri" pitchFamily="34" charset="-122"/>
                 <a:cs typeface="Calibri" pitchFamily="34" charset="-120"/>
               </a:rPr>
-              <a:t>Model choice is itself a finding — see the evaluation.</a:t>
+              <a:t>Model choice is itself a finding - see the evaluation.</a:t>
             </a:r>
             <a:endParaRPr lang="en-US" sz="1500" dirty="0"/>
           </a:p>
@@ -4961,6 +4930,7 @@
         <a:solidFill>
           <a:srgbClr val="0B1E3D"/>
         </a:solidFill>
+        <a:effectLst/>
       </p:bgPr>
     </p:bg>
     <p:spTree>
@@ -4998,6 +4968,13 @@
           </a:solidFill>
           <a:ln/>
         </p:spPr>
+        <p:txBody>
+          <a:bodyPr/>
+          <a:lstStyle/>
+          <a:p>
+            <a:endParaRPr lang="en-US"/>
+          </a:p>
+        </p:txBody>
       </p:sp>
       <p:sp>
         <p:nvSpPr>
@@ -5020,7 +4997,7 @@
           <a:bodyPr wrap="square" lIns="0" tIns="0" rIns="0" bIns="0" rtlCol="0" anchor="ctr"/>
           <a:lstStyle/>
           <a:p>
-            <a:pPr algn="ctr" indent="0" marL="0">
+            <a:pPr marL="0" indent="0" algn="ctr">
               <a:buNone/>
             </a:pPr>
             <a:r>
@@ -5032,7 +5009,7 @@
                 <a:ea typeface="Calibri" pitchFamily="34" charset="-122"/>
                 <a:cs typeface="Calibri" pitchFamily="34" charset="-120"/>
               </a:rPr>
-              <a:t>How it works  [50 pts]</a:t>
+              <a:t>How it works </a:t>
             </a:r>
             <a:endParaRPr lang="en-US" sz="1200" dirty="0"/>
           </a:p>
@@ -5059,7 +5036,7 @@
           <a:bodyPr wrap="square" lIns="0" tIns="0" rIns="0" bIns="0" rtlCol="0" anchor="ctr"/>
           <a:lstStyle/>
           <a:p>
-            <a:pPr indent="0" marL="0">
+            <a:pPr marL="0" indent="0">
               <a:buNone/>
             </a:pPr>
             <a:r>
@@ -5103,13 +5080,20 @@
             <a:prstDash val="solid"/>
           </a:ln>
           <a:effectLst>
-            <a:outerShdw sx="100000" sy="100000" kx="0" ky="0" algn="bl" rotWithShape="0" blurRad="101600" dist="38100" dir="5400000">
+            <a:outerShdw blurRad="101600" dist="38100" dir="5400000" algn="bl" rotWithShape="0">
               <a:srgbClr val="071018">
                 <a:alpha val="45000"/>
               </a:srgbClr>
             </a:outerShdw>
           </a:effectLst>
         </p:spPr>
+        <p:txBody>
+          <a:bodyPr/>
+          <a:lstStyle/>
+          <a:p>
+            <a:endParaRPr lang="en-US"/>
+          </a:p>
+        </p:txBody>
       </p:sp>
       <p:sp>
         <p:nvSpPr>
@@ -5130,6 +5114,13 @@
           </a:solidFill>
           <a:ln/>
         </p:spPr>
+        <p:txBody>
+          <a:bodyPr/>
+          <a:lstStyle/>
+          <a:p>
+            <a:endParaRPr lang="en-US"/>
+          </a:p>
+        </p:txBody>
       </p:sp>
       <p:sp>
         <p:nvSpPr>
@@ -5152,7 +5143,7 @@
           <a:bodyPr wrap="square" lIns="0" tIns="0" rIns="0" bIns="0" rtlCol="0" anchor="ctr"/>
           <a:lstStyle/>
           <a:p>
-            <a:pPr algn="ctr" indent="0" marL="0">
+            <a:pPr marL="0" indent="0" algn="ctr">
               <a:buNone/>
             </a:pPr>
             <a:r>
@@ -5191,7 +5182,7 @@
           <a:bodyPr wrap="square" lIns="0" tIns="0" rIns="0" bIns="0" rtlCol="0" anchor="ctr"/>
           <a:lstStyle/>
           <a:p>
-            <a:pPr algn="ctr" indent="0" marL="0">
+            <a:pPr marL="0" indent="0" algn="ctr">
               <a:buNone/>
             </a:pPr>
             <a:r>
@@ -5230,7 +5221,7 @@
           <a:bodyPr wrap="square" lIns="0" tIns="0" rIns="0" bIns="0" rtlCol="0" anchor="ctr"/>
           <a:lstStyle/>
           <a:p>
-            <a:pPr algn="ctr" indent="0" marL="0">
+            <a:pPr marL="0" indent="0" algn="ctr">
               <a:buNone/>
             </a:pPr>
             <a:r>
@@ -5247,7 +5238,7 @@
             <a:endParaRPr lang="en-US" sz="1300" dirty="0"/>
           </a:p>
           <a:p>
-            <a:pPr algn="ctr" indent="0" marL="0">
+            <a:pPr marL="0" indent="0" algn="ctr">
               <a:buNone/>
             </a:pPr>
             <a:r>
@@ -5286,7 +5277,7 @@
           <a:bodyPr wrap="square" lIns="0" tIns="0" rIns="0" bIns="0" rtlCol="0" anchor="ctr"/>
           <a:lstStyle/>
           <a:p>
-            <a:pPr algn="ctr" indent="0" marL="0">
+            <a:pPr marL="0" indent="0" algn="ctr">
               <a:buNone/>
             </a:pPr>
             <a:r>
@@ -5327,13 +5318,20 @@
             <a:prstDash val="solid"/>
           </a:ln>
           <a:effectLst>
-            <a:outerShdw sx="100000" sy="100000" kx="0" ky="0" algn="bl" rotWithShape="0" blurRad="101600" dist="38100" dir="5400000">
+            <a:outerShdw blurRad="101600" dist="38100" dir="5400000" algn="bl" rotWithShape="0">
               <a:srgbClr val="071018">
                 <a:alpha val="45000"/>
               </a:srgbClr>
             </a:outerShdw>
           </a:effectLst>
         </p:spPr>
+        <p:txBody>
+          <a:bodyPr/>
+          <a:lstStyle/>
+          <a:p>
+            <a:endParaRPr lang="en-US"/>
+          </a:p>
+        </p:txBody>
       </p:sp>
       <p:sp>
         <p:nvSpPr>
@@ -5354,6 +5352,13 @@
           </a:solidFill>
           <a:ln/>
         </p:spPr>
+        <p:txBody>
+          <a:bodyPr/>
+          <a:lstStyle/>
+          <a:p>
+            <a:endParaRPr lang="en-US"/>
+          </a:p>
+        </p:txBody>
       </p:sp>
       <p:sp>
         <p:nvSpPr>
@@ -5376,7 +5381,7 @@
           <a:bodyPr wrap="square" lIns="0" tIns="0" rIns="0" bIns="0" rtlCol="0" anchor="ctr"/>
           <a:lstStyle/>
           <a:p>
-            <a:pPr algn="ctr" indent="0" marL="0">
+            <a:pPr marL="0" indent="0" algn="ctr">
               <a:buNone/>
             </a:pPr>
             <a:r>
@@ -5415,7 +5420,7 @@
           <a:bodyPr wrap="square" lIns="0" tIns="0" rIns="0" bIns="0" rtlCol="0" anchor="ctr"/>
           <a:lstStyle/>
           <a:p>
-            <a:pPr algn="ctr" indent="0" marL="0">
+            <a:pPr marL="0" indent="0" algn="ctr">
               <a:buNone/>
             </a:pPr>
             <a:r>
@@ -5454,7 +5459,7 @@
           <a:bodyPr wrap="square" lIns="0" tIns="0" rIns="0" bIns="0" rtlCol="0" anchor="ctr"/>
           <a:lstStyle/>
           <a:p>
-            <a:pPr algn="ctr" indent="0" marL="0">
+            <a:pPr marL="0" indent="0" algn="ctr">
               <a:buNone/>
             </a:pPr>
             <a:r>
@@ -5471,7 +5476,7 @@
             <a:endParaRPr lang="en-US" sz="1300" dirty="0"/>
           </a:p>
           <a:p>
-            <a:pPr algn="ctr" indent="0" marL="0">
+            <a:pPr marL="0" indent="0" algn="ctr">
               <a:buNone/>
             </a:pPr>
             <a:r>
@@ -5510,7 +5515,7 @@
           <a:bodyPr wrap="square" lIns="0" tIns="0" rIns="0" bIns="0" rtlCol="0" anchor="ctr"/>
           <a:lstStyle/>
           <a:p>
-            <a:pPr algn="ctr" indent="0" marL="0">
+            <a:pPr marL="0" indent="0" algn="ctr">
               <a:buNone/>
             </a:pPr>
             <a:r>
@@ -5551,13 +5556,20 @@
             <a:prstDash val="solid"/>
           </a:ln>
           <a:effectLst>
-            <a:outerShdw sx="100000" sy="100000" kx="0" ky="0" algn="bl" rotWithShape="0" blurRad="101600" dist="38100" dir="5400000">
+            <a:outerShdw blurRad="101600" dist="38100" dir="5400000" algn="bl" rotWithShape="0">
               <a:srgbClr val="071018">
                 <a:alpha val="45000"/>
               </a:srgbClr>
             </a:outerShdw>
           </a:effectLst>
         </p:spPr>
+        <p:txBody>
+          <a:bodyPr/>
+          <a:lstStyle/>
+          <a:p>
+            <a:endParaRPr lang="en-US"/>
+          </a:p>
+        </p:txBody>
       </p:sp>
       <p:sp>
         <p:nvSpPr>
@@ -5578,6 +5590,13 @@
           </a:solidFill>
           <a:ln/>
         </p:spPr>
+        <p:txBody>
+          <a:bodyPr/>
+          <a:lstStyle/>
+          <a:p>
+            <a:endParaRPr lang="en-US"/>
+          </a:p>
+        </p:txBody>
       </p:sp>
       <p:sp>
         <p:nvSpPr>
@@ -5600,7 +5619,7 @@
           <a:bodyPr wrap="square" lIns="0" tIns="0" rIns="0" bIns="0" rtlCol="0" anchor="ctr"/>
           <a:lstStyle/>
           <a:p>
-            <a:pPr algn="ctr" indent="0" marL="0">
+            <a:pPr marL="0" indent="0" algn="ctr">
               <a:buNone/>
             </a:pPr>
             <a:r>
@@ -5639,7 +5658,7 @@
           <a:bodyPr wrap="square" lIns="0" tIns="0" rIns="0" bIns="0" rtlCol="0" anchor="ctr"/>
           <a:lstStyle/>
           <a:p>
-            <a:pPr algn="ctr" indent="0" marL="0">
+            <a:pPr marL="0" indent="0" algn="ctr">
               <a:buNone/>
             </a:pPr>
             <a:r>
@@ -5678,7 +5697,7 @@
           <a:bodyPr wrap="square" lIns="0" tIns="0" rIns="0" bIns="0" rtlCol="0" anchor="ctr"/>
           <a:lstStyle/>
           <a:p>
-            <a:pPr algn="ctr" indent="0" marL="0">
+            <a:pPr marL="0" indent="0" algn="ctr">
               <a:buNone/>
             </a:pPr>
             <a:r>
@@ -5695,7 +5714,7 @@
             <a:endParaRPr lang="en-US" sz="1300" dirty="0"/>
           </a:p>
           <a:p>
-            <a:pPr algn="ctr" indent="0" marL="0">
+            <a:pPr marL="0" indent="0" algn="ctr">
               <a:buNone/>
             </a:pPr>
             <a:r>
@@ -5734,7 +5753,7 @@
           <a:bodyPr wrap="square" lIns="0" tIns="0" rIns="0" bIns="0" rtlCol="0" anchor="ctr"/>
           <a:lstStyle/>
           <a:p>
-            <a:pPr algn="ctr" indent="0" marL="0">
+            <a:pPr marL="0" indent="0" algn="ctr">
               <a:buNone/>
             </a:pPr>
             <a:r>
@@ -5775,13 +5794,20 @@
             <a:prstDash val="solid"/>
           </a:ln>
           <a:effectLst>
-            <a:outerShdw sx="100000" sy="100000" kx="0" ky="0" algn="bl" rotWithShape="0" blurRad="101600" dist="38100" dir="5400000">
+            <a:outerShdw blurRad="101600" dist="38100" dir="5400000" algn="bl" rotWithShape="0">
               <a:srgbClr val="071018">
                 <a:alpha val="45000"/>
               </a:srgbClr>
             </a:outerShdw>
           </a:effectLst>
         </p:spPr>
+        <p:txBody>
+          <a:bodyPr/>
+          <a:lstStyle/>
+          <a:p>
+            <a:endParaRPr lang="en-US"/>
+          </a:p>
+        </p:txBody>
       </p:sp>
       <p:sp>
         <p:nvSpPr>
@@ -5802,6 +5828,13 @@
           </a:solidFill>
           <a:ln/>
         </p:spPr>
+        <p:txBody>
+          <a:bodyPr/>
+          <a:lstStyle/>
+          <a:p>
+            <a:endParaRPr lang="en-US"/>
+          </a:p>
+        </p:txBody>
       </p:sp>
       <p:sp>
         <p:nvSpPr>
@@ -5824,7 +5857,7 @@
           <a:bodyPr wrap="square" lIns="0" tIns="0" rIns="0" bIns="0" rtlCol="0" anchor="ctr"/>
           <a:lstStyle/>
           <a:p>
-            <a:pPr algn="ctr" indent="0" marL="0">
+            <a:pPr marL="0" indent="0" algn="ctr">
               <a:buNone/>
             </a:pPr>
             <a:r>
@@ -5863,7 +5896,7 @@
           <a:bodyPr wrap="square" lIns="0" tIns="0" rIns="0" bIns="0" rtlCol="0" anchor="ctr"/>
           <a:lstStyle/>
           <a:p>
-            <a:pPr algn="ctr" indent="0" marL="0">
+            <a:pPr marL="0" indent="0" algn="ctr">
               <a:buNone/>
             </a:pPr>
             <a:r>
@@ -5902,7 +5935,7 @@
           <a:bodyPr wrap="square" lIns="0" tIns="0" rIns="0" bIns="0" rtlCol="0" anchor="ctr"/>
           <a:lstStyle/>
           <a:p>
-            <a:pPr algn="ctr" indent="0" marL="0">
+            <a:pPr marL="0" indent="0" algn="ctr">
               <a:buNone/>
             </a:pPr>
             <a:r>
@@ -5919,7 +5952,7 @@
             <a:endParaRPr lang="en-US" sz="1300" dirty="0"/>
           </a:p>
           <a:p>
-            <a:pPr algn="ctr" indent="0" marL="0">
+            <a:pPr marL="0" indent="0" algn="ctr">
               <a:buNone/>
             </a:pPr>
             <a:r>
@@ -5958,7 +5991,7 @@
           <a:bodyPr wrap="square" lIns="0" tIns="0" rIns="0" bIns="0" rtlCol="0" anchor="ctr"/>
           <a:lstStyle/>
           <a:p>
-            <a:pPr algn="ctr" indent="0" marL="0">
+            <a:pPr marL="0" indent="0" algn="ctr">
               <a:buNone/>
             </a:pPr>
             <a:r>
@@ -5999,13 +6032,20 @@
             <a:prstDash val="solid"/>
           </a:ln>
           <a:effectLst>
-            <a:outerShdw sx="100000" sy="100000" kx="0" ky="0" algn="bl" rotWithShape="0" blurRad="101600" dist="38100" dir="5400000">
+            <a:outerShdw blurRad="101600" dist="38100" dir="5400000" algn="bl" rotWithShape="0">
               <a:srgbClr val="071018">
                 <a:alpha val="45000"/>
               </a:srgbClr>
             </a:outerShdw>
           </a:effectLst>
         </p:spPr>
+        <p:txBody>
+          <a:bodyPr/>
+          <a:lstStyle/>
+          <a:p>
+            <a:endParaRPr lang="en-US"/>
+          </a:p>
+        </p:txBody>
       </p:sp>
       <p:sp>
         <p:nvSpPr>
@@ -6026,6 +6066,13 @@
           </a:solidFill>
           <a:ln/>
         </p:spPr>
+        <p:txBody>
+          <a:bodyPr/>
+          <a:lstStyle/>
+          <a:p>
+            <a:endParaRPr lang="en-US"/>
+          </a:p>
+        </p:txBody>
       </p:sp>
       <p:sp>
         <p:nvSpPr>
@@ -6048,7 +6095,7 @@
           <a:bodyPr wrap="square" lIns="0" tIns="0" rIns="0" bIns="0" rtlCol="0" anchor="ctr"/>
           <a:lstStyle/>
           <a:p>
-            <a:pPr algn="ctr" indent="0" marL="0">
+            <a:pPr marL="0" indent="0" algn="ctr">
               <a:buNone/>
             </a:pPr>
             <a:r>
@@ -6087,7 +6134,7 @@
           <a:bodyPr wrap="square" lIns="0" tIns="0" rIns="0" bIns="0" rtlCol="0" anchor="ctr"/>
           <a:lstStyle/>
           <a:p>
-            <a:pPr algn="ctr" indent="0" marL="0">
+            <a:pPr marL="0" indent="0" algn="ctr">
               <a:buNone/>
             </a:pPr>
             <a:r>
@@ -6126,7 +6173,7 @@
           <a:bodyPr wrap="square" lIns="0" tIns="0" rIns="0" bIns="0" rtlCol="0" anchor="ctr"/>
           <a:lstStyle/>
           <a:p>
-            <a:pPr algn="ctr" indent="0" marL="0">
+            <a:pPr marL="0" indent="0" algn="ctr">
               <a:buNone/>
             </a:pPr>
             <a:r>
@@ -6143,7 +6190,7 @@
             <a:endParaRPr lang="en-US" sz="1300" dirty="0"/>
           </a:p>
           <a:p>
-            <a:pPr algn="ctr" indent="0" marL="0">
+            <a:pPr marL="0" indent="0" algn="ctr">
               <a:buNone/>
             </a:pPr>
             <a:r>
@@ -6182,7 +6229,7 @@
           <a:bodyPr wrap="square" lIns="0" tIns="0" rIns="0" bIns="0" rtlCol="0" anchor="ctr"/>
           <a:lstStyle/>
           <a:p>
-            <a:pPr indent="0" marL="0">
+            <a:pPr marL="0" indent="0">
               <a:buNone/>
             </a:pPr>
             <a:r>
@@ -6194,7 +6241,7 @@
                 <a:ea typeface="Calibri" pitchFamily="34" charset="-122"/>
                 <a:cs typeface="Calibri" pitchFamily="34" charset="-120"/>
               </a:rPr>
-              <a:t>Zero-dependency Python server (stdlib only); auto-detects Ollama, and falls back to a deterministic mock so it runs anywhere.</a:t>
+              <a:t>Zero-dependency Python server (stdlib only), auto-detects Ollama, and falls back to a deterministic mock so it runs anywhere.</a:t>
             </a:r>
             <a:endParaRPr lang="en-US" sz="1500" dirty="0"/>
           </a:p>
@@ -6216,6 +6263,7 @@
         <a:solidFill>
           <a:srgbClr val="0B1E3D"/>
         </a:solidFill>
+        <a:effectLst/>
       </p:bgPr>
     </p:bg>
     <p:spTree>
@@ -6240,7 +6288,7 @@
         </p:nvSpPr>
         <p:spPr>
           <a:xfrm>
-            <a:off x="640080" y="502920"/>
+            <a:off x="640080" y="310420"/>
             <a:ext cx="2172614" cy="329184"/>
           </a:xfrm>
           <a:prstGeom prst="roundRect">
@@ -6253,6 +6301,13 @@
           </a:solidFill>
           <a:ln/>
         </p:spPr>
+        <p:txBody>
+          <a:bodyPr/>
+          <a:lstStyle/>
+          <a:p>
+            <a:endParaRPr lang="en-US"/>
+          </a:p>
+        </p:txBody>
       </p:sp>
       <p:sp>
         <p:nvSpPr>
@@ -6262,7 +6317,7 @@
         </p:nvSpPr>
         <p:spPr>
           <a:xfrm>
-            <a:off x="640080" y="502920"/>
+            <a:off x="640080" y="310420"/>
             <a:ext cx="2172614" cy="329184"/>
           </a:xfrm>
           <a:prstGeom prst="rect">
@@ -6275,7 +6330,7 @@
           <a:bodyPr wrap="square" lIns="0" tIns="0" rIns="0" bIns="0" rtlCol="0" anchor="ctr"/>
           <a:lstStyle/>
           <a:p>
-            <a:pPr algn="ctr" indent="0" marL="0">
+            <a:pPr marL="0" indent="0" algn="ctr">
               <a:buNone/>
             </a:pPr>
             <a:r>
@@ -6287,7 +6342,7 @@
                 <a:ea typeface="Calibri" pitchFamily="34" charset="-122"/>
                 <a:cs typeface="Calibri" pitchFamily="34" charset="-120"/>
               </a:rPr>
-              <a:t>Capabilities  [10 pts]</a:t>
+              <a:t>Capabilities </a:t>
             </a:r>
             <a:endParaRPr lang="en-US" sz="1200" dirty="0"/>
           </a:p>
@@ -6301,7 +6356,7 @@
         </p:nvSpPr>
         <p:spPr>
           <a:xfrm>
-            <a:off x="640080" y="868680"/>
+            <a:off x="640080" y="676180"/>
             <a:ext cx="10972800" cy="822960"/>
           </a:xfrm>
           <a:prstGeom prst="rect">
@@ -6314,7 +6369,7 @@
           <a:bodyPr wrap="square" lIns="0" tIns="0" rIns="0" bIns="0" rtlCol="0" anchor="ctr"/>
           <a:lstStyle/>
           <a:p>
-            <a:pPr indent="0" marL="0">
+            <a:pPr marL="0" indent="0">
               <a:buNone/>
             </a:pPr>
             <a:r>
@@ -6340,7 +6395,7 @@
         </p:nvSpPr>
         <p:spPr>
           <a:xfrm>
-            <a:off x="640080" y="1965960"/>
+            <a:off x="640080" y="1475085"/>
             <a:ext cx="5303520" cy="1463040"/>
           </a:xfrm>
           <a:prstGeom prst="roundRect">
@@ -6358,13 +6413,21 @@
             <a:prstDash val="solid"/>
           </a:ln>
           <a:effectLst>
-            <a:outerShdw sx="100000" sy="100000" kx="0" ky="0" algn="bl" rotWithShape="0" blurRad="101600" dist="38100" dir="5400000">
+            <a:outerShdw blurRad="101600" dist="38100" dir="5400000" algn="bl" rotWithShape="0">
               <a:srgbClr val="071018">
                 <a:alpha val="45000"/>
               </a:srgbClr>
             </a:outerShdw>
           </a:effectLst>
         </p:spPr>
+        <p:txBody>
+          <a:bodyPr/>
+          <a:lstStyle/>
+          <a:p>
+            <a:pPr marL="0" algn="r" defTabSz="914400" rtl="1" eaLnBrk="1" latinLnBrk="0" hangingPunct="1"/>
+            <a:endParaRPr lang="en-US"/>
+          </a:p>
+        </p:txBody>
       </p:sp>
       <p:sp>
         <p:nvSpPr>
@@ -6374,7 +6437,7 @@
         </p:nvSpPr>
         <p:spPr>
           <a:xfrm>
-            <a:off x="896112" y="2258568"/>
+            <a:off x="896112" y="1767693"/>
             <a:ext cx="502920" cy="502920"/>
           </a:xfrm>
           <a:prstGeom prst="ellipse">
@@ -6385,6 +6448,13 @@
           </a:solidFill>
           <a:ln/>
         </p:spPr>
+        <p:txBody>
+          <a:bodyPr/>
+          <a:lstStyle/>
+          <a:p>
+            <a:endParaRPr lang="en-US"/>
+          </a:p>
+        </p:txBody>
       </p:sp>
       <p:sp>
         <p:nvSpPr>
@@ -6394,7 +6464,7 @@
         </p:nvSpPr>
         <p:spPr>
           <a:xfrm>
-            <a:off x="896112" y="2258568"/>
+            <a:off x="896112" y="1767693"/>
             <a:ext cx="502920" cy="502920"/>
           </a:xfrm>
           <a:prstGeom prst="rect">
@@ -6407,7 +6477,7 @@
           <a:bodyPr wrap="square" lIns="0" tIns="0" rIns="0" bIns="0" rtlCol="0" anchor="ctr"/>
           <a:lstStyle/>
           <a:p>
-            <a:pPr algn="ctr" indent="0" marL="0">
+            <a:pPr marL="0" indent="0" algn="ctr">
               <a:buNone/>
             </a:pPr>
             <a:r>
@@ -6433,7 +6503,7 @@
         </p:nvSpPr>
         <p:spPr>
           <a:xfrm>
-            <a:off x="1600200" y="2167128"/>
+            <a:off x="1600200" y="1676253"/>
             <a:ext cx="4206240" cy="457200"/>
           </a:xfrm>
           <a:prstGeom prst="rect">
@@ -6446,7 +6516,7 @@
           <a:bodyPr wrap="square" lIns="0" tIns="0" rIns="0" bIns="0" rtlCol="0" anchor="ctr"/>
           <a:lstStyle/>
           <a:p>
-            <a:pPr indent="0" marL="0">
+            <a:pPr marL="0" indent="0">
               <a:buNone/>
             </a:pPr>
             <a:r>
@@ -6472,7 +6542,7 @@
         </p:nvSpPr>
         <p:spPr>
           <a:xfrm>
-            <a:off x="1600200" y="2624328"/>
+            <a:off x="1600200" y="2133453"/>
             <a:ext cx="4206240" cy="731520"/>
           </a:xfrm>
           <a:prstGeom prst="rect">
@@ -6485,7 +6555,7 @@
           <a:bodyPr wrap="square" lIns="0" tIns="0" rIns="0" bIns="0" rtlCol="0" anchor="ctr"/>
           <a:lstStyle/>
           <a:p>
-            <a:pPr indent="0" marL="0">
+            <a:pPr marL="0" indent="0">
               <a:buNone/>
             </a:pPr>
             <a:r>
@@ -6497,7 +6567,7 @@
                 <a:ea typeface="Calibri" pitchFamily="34" charset="-122"/>
                 <a:cs typeface="Calibri" pitchFamily="34" charset="-120"/>
               </a:rPr>
-              <a:t>Turns a P1–P9 provenance record into an auditable narrative and checks internal consistency.</a:t>
+              <a:t>Turns a P1-P9 provenance record into an auditable narrative and checks internal consistency.</a:t>
             </a:r>
             <a:endParaRPr lang="en-US" sz="1400" dirty="0"/>
           </a:p>
@@ -6511,7 +6581,7 @@
         </p:nvSpPr>
         <p:spPr>
           <a:xfrm>
-            <a:off x="6217920" y="1965960"/>
+            <a:off x="6217920" y="1475085"/>
             <a:ext cx="5303520" cy="1463040"/>
           </a:xfrm>
           <a:prstGeom prst="roundRect">
@@ -6529,13 +6599,20 @@
             <a:prstDash val="solid"/>
           </a:ln>
           <a:effectLst>
-            <a:outerShdw sx="100000" sy="100000" kx="0" ky="0" algn="bl" rotWithShape="0" blurRad="101600" dist="38100" dir="5400000">
+            <a:outerShdw blurRad="101600" dist="38100" dir="5400000" algn="bl" rotWithShape="0">
               <a:srgbClr val="071018">
                 <a:alpha val="45000"/>
               </a:srgbClr>
             </a:outerShdw>
           </a:effectLst>
         </p:spPr>
+        <p:txBody>
+          <a:bodyPr/>
+          <a:lstStyle/>
+          <a:p>
+            <a:endParaRPr lang="en-US"/>
+          </a:p>
+        </p:txBody>
       </p:sp>
       <p:sp>
         <p:nvSpPr>
@@ -6545,7 +6622,7 @@
         </p:nvSpPr>
         <p:spPr>
           <a:xfrm>
-            <a:off x="6473952" y="2258568"/>
+            <a:off x="6473952" y="1767693"/>
             <a:ext cx="502920" cy="502920"/>
           </a:xfrm>
           <a:prstGeom prst="ellipse">
@@ -6556,6 +6633,13 @@
           </a:solidFill>
           <a:ln/>
         </p:spPr>
+        <p:txBody>
+          <a:bodyPr/>
+          <a:lstStyle/>
+          <a:p>
+            <a:endParaRPr lang="en-US"/>
+          </a:p>
+        </p:txBody>
       </p:sp>
       <p:sp>
         <p:nvSpPr>
@@ -6565,7 +6649,7 @@
         </p:nvSpPr>
         <p:spPr>
           <a:xfrm>
-            <a:off x="6473952" y="2258568"/>
+            <a:off x="6473952" y="1767693"/>
             <a:ext cx="502920" cy="502920"/>
           </a:xfrm>
           <a:prstGeom prst="rect">
@@ -6578,7 +6662,7 @@
           <a:bodyPr wrap="square" lIns="0" tIns="0" rIns="0" bIns="0" rtlCol="0" anchor="ctr"/>
           <a:lstStyle/>
           <a:p>
-            <a:pPr algn="ctr" indent="0" marL="0">
+            <a:pPr marL="0" indent="0" algn="ctr">
               <a:buNone/>
             </a:pPr>
             <a:r>
@@ -6604,7 +6688,7 @@
         </p:nvSpPr>
         <p:spPr>
           <a:xfrm>
-            <a:off x="7178040" y="2167128"/>
+            <a:off x="7178040" y="1676253"/>
             <a:ext cx="4206240" cy="457200"/>
           </a:xfrm>
           <a:prstGeom prst="rect">
@@ -6617,7 +6701,7 @@
           <a:bodyPr wrap="square" lIns="0" tIns="0" rIns="0" bIns="0" rtlCol="0" anchor="ctr"/>
           <a:lstStyle/>
           <a:p>
-            <a:pPr indent="0" marL="0">
+            <a:pPr marL="0" indent="0">
               <a:buNone/>
             </a:pPr>
             <a:r>
@@ -6643,7 +6727,7 @@
         </p:nvSpPr>
         <p:spPr>
           <a:xfrm>
-            <a:off x="7178040" y="2624328"/>
+            <a:off x="7178040" y="2133453"/>
             <a:ext cx="4206240" cy="731520"/>
           </a:xfrm>
           <a:prstGeom prst="rect">
@@ -6656,7 +6740,7 @@
           <a:bodyPr wrap="square" lIns="0" tIns="0" rIns="0" bIns="0" rtlCol="0" anchor="ctr"/>
           <a:lstStyle/>
           <a:p>
-            <a:pPr indent="0" marL="0">
+            <a:pPr marL="0" indent="0">
               <a:buNone/>
             </a:pPr>
             <a:r>
@@ -6668,7 +6752,7 @@
                 <a:ea typeface="Calibri" pitchFamily="34" charset="-122"/>
                 <a:cs typeface="Calibri" pitchFamily="34" charset="-120"/>
               </a:rPr>
-              <a:t>Explains why a tumor-suppressor mutation is non-druggable — grounded in literature, with citations.</a:t>
+              <a:t>Explains why a tumor-suppressor mutation is non-druggable - grounded in literature, with citations.</a:t>
             </a:r>
             <a:endParaRPr lang="en-US" sz="1400" dirty="0"/>
           </a:p>
@@ -6682,7 +6766,7 @@
         </p:nvSpPr>
         <p:spPr>
           <a:xfrm>
-            <a:off x="640080" y="3657600"/>
+            <a:off x="640080" y="3166725"/>
             <a:ext cx="5303520" cy="1463040"/>
           </a:xfrm>
           <a:prstGeom prst="roundRect">
@@ -6700,13 +6784,20 @@
             <a:prstDash val="solid"/>
           </a:ln>
           <a:effectLst>
-            <a:outerShdw sx="100000" sy="100000" kx="0" ky="0" algn="bl" rotWithShape="0" blurRad="101600" dist="38100" dir="5400000">
+            <a:outerShdw blurRad="101600" dist="38100" dir="5400000" algn="bl" rotWithShape="0">
               <a:srgbClr val="071018">
                 <a:alpha val="45000"/>
               </a:srgbClr>
             </a:outerShdw>
           </a:effectLst>
         </p:spPr>
+        <p:txBody>
+          <a:bodyPr/>
+          <a:lstStyle/>
+          <a:p>
+            <a:endParaRPr lang="en-US"/>
+          </a:p>
+        </p:txBody>
       </p:sp>
       <p:sp>
         <p:nvSpPr>
@@ -6716,7 +6807,7 @@
         </p:nvSpPr>
         <p:spPr>
           <a:xfrm>
-            <a:off x="896112" y="3950208"/>
+            <a:off x="896112" y="3459333"/>
             <a:ext cx="502920" cy="502920"/>
           </a:xfrm>
           <a:prstGeom prst="ellipse">
@@ -6727,6 +6818,13 @@
           </a:solidFill>
           <a:ln/>
         </p:spPr>
+        <p:txBody>
+          <a:bodyPr/>
+          <a:lstStyle/>
+          <a:p>
+            <a:endParaRPr lang="en-US"/>
+          </a:p>
+        </p:txBody>
       </p:sp>
       <p:sp>
         <p:nvSpPr>
@@ -6736,7 +6834,7 @@
         </p:nvSpPr>
         <p:spPr>
           <a:xfrm>
-            <a:off x="896112" y="3950208"/>
+            <a:off x="896112" y="3459333"/>
             <a:ext cx="502920" cy="502920"/>
           </a:xfrm>
           <a:prstGeom prst="rect">
@@ -6749,7 +6847,7 @@
           <a:bodyPr wrap="square" lIns="0" tIns="0" rIns="0" bIns="0" rtlCol="0" anchor="ctr"/>
           <a:lstStyle/>
           <a:p>
-            <a:pPr algn="ctr" indent="0" marL="0">
+            <a:pPr marL="0" indent="0" algn="ctr">
               <a:buNone/>
             </a:pPr>
             <a:r>
@@ -6775,7 +6873,7 @@
         </p:nvSpPr>
         <p:spPr>
           <a:xfrm>
-            <a:off x="1600200" y="3858768"/>
+            <a:off x="1600200" y="3367893"/>
             <a:ext cx="4206240" cy="457200"/>
           </a:xfrm>
           <a:prstGeom prst="rect">
@@ -6788,7 +6886,7 @@
           <a:bodyPr wrap="square" lIns="0" tIns="0" rIns="0" bIns="0" rtlCol="0" anchor="ctr"/>
           <a:lstStyle/>
           <a:p>
-            <a:pPr indent="0" marL="0">
+            <a:pPr marL="0" indent="0">
               <a:buNone/>
             </a:pPr>
             <a:r>
@@ -6814,7 +6912,7 @@
         </p:nvSpPr>
         <p:spPr>
           <a:xfrm>
-            <a:off x="1600200" y="4315968"/>
+            <a:off x="1600200" y="3825093"/>
             <a:ext cx="4206240" cy="731520"/>
           </a:xfrm>
           <a:prstGeom prst="rect">
@@ -6827,7 +6925,7 @@
           <a:bodyPr wrap="square" lIns="0" tIns="0" rIns="0" bIns="0" rtlCol="0" anchor="ctr"/>
           <a:lstStyle/>
           <a:p>
-            <a:pPr indent="0" marL="0">
+            <a:pPr marL="0" indent="0">
               <a:buNone/>
             </a:pPr>
             <a:r>
@@ -6839,7 +6937,7 @@
                 <a:ea typeface="Calibri" pitchFamily="34" charset="-122"/>
                 <a:cs typeface="Calibri" pitchFamily="34" charset="-120"/>
               </a:rPr>
-              <a:t>Recomputes the P8 SHA-256 seal locally and detects tampering — offline.</a:t>
+              <a:t>Recomputes the P8 SHA-256 seal locally and detects tampering - offline.</a:t>
             </a:r>
             <a:endParaRPr lang="en-US" sz="1400" dirty="0"/>
           </a:p>
@@ -6853,7 +6951,7 @@
         </p:nvSpPr>
         <p:spPr>
           <a:xfrm>
-            <a:off x="6217920" y="3657600"/>
+            <a:off x="6217920" y="3166725"/>
             <a:ext cx="5303520" cy="1463040"/>
           </a:xfrm>
           <a:prstGeom prst="roundRect">
@@ -6871,13 +6969,20 @@
             <a:prstDash val="solid"/>
           </a:ln>
           <a:effectLst>
-            <a:outerShdw sx="100000" sy="100000" kx="0" ky="0" algn="bl" rotWithShape="0" blurRad="101600" dist="38100" dir="5400000">
+            <a:outerShdw blurRad="101600" dist="38100" dir="5400000" algn="bl" rotWithShape="0">
               <a:srgbClr val="071018">
                 <a:alpha val="45000"/>
               </a:srgbClr>
             </a:outerShdw>
           </a:effectLst>
         </p:spPr>
+        <p:txBody>
+          <a:bodyPr/>
+          <a:lstStyle/>
+          <a:p>
+            <a:endParaRPr lang="en-US"/>
+          </a:p>
+        </p:txBody>
       </p:sp>
       <p:sp>
         <p:nvSpPr>
@@ -6887,7 +6992,7 @@
         </p:nvSpPr>
         <p:spPr>
           <a:xfrm>
-            <a:off x="6473952" y="3950208"/>
+            <a:off x="6473952" y="3459333"/>
             <a:ext cx="502920" cy="502920"/>
           </a:xfrm>
           <a:prstGeom prst="ellipse">
@@ -6898,6 +7003,13 @@
           </a:solidFill>
           <a:ln/>
         </p:spPr>
+        <p:txBody>
+          <a:bodyPr/>
+          <a:lstStyle/>
+          <a:p>
+            <a:endParaRPr lang="en-US"/>
+          </a:p>
+        </p:txBody>
       </p:sp>
       <p:sp>
         <p:nvSpPr>
@@ -6907,7 +7019,7 @@
         </p:nvSpPr>
         <p:spPr>
           <a:xfrm>
-            <a:off x="6473952" y="3950208"/>
+            <a:off x="6473952" y="3459333"/>
             <a:ext cx="502920" cy="502920"/>
           </a:xfrm>
           <a:prstGeom prst="rect">
@@ -6920,7 +7032,7 @@
           <a:bodyPr wrap="square" lIns="0" tIns="0" rIns="0" bIns="0" rtlCol="0" anchor="ctr"/>
           <a:lstStyle/>
           <a:p>
-            <a:pPr algn="ctr" indent="0" marL="0">
+            <a:pPr marL="0" indent="0" algn="ctr">
               <a:buNone/>
             </a:pPr>
             <a:r>
@@ -6946,7 +7058,7 @@
         </p:nvSpPr>
         <p:spPr>
           <a:xfrm>
-            <a:off x="7178040" y="3858768"/>
+            <a:off x="7137848" y="3367893"/>
             <a:ext cx="4206240" cy="457200"/>
           </a:xfrm>
           <a:prstGeom prst="rect">
@@ -6959,7 +7071,7 @@
           <a:bodyPr wrap="square" lIns="0" tIns="0" rIns="0" bIns="0" rtlCol="0" anchor="ctr"/>
           <a:lstStyle/>
           <a:p>
-            <a:pPr indent="0" marL="0">
+            <a:pPr marL="0" indent="0">
               <a:buNone/>
             </a:pPr>
             <a:r>
@@ -6985,20 +7097,20 @@
         </p:nvSpPr>
         <p:spPr>
           <a:xfrm>
-            <a:off x="7178040" y="4315968"/>
-            <a:ext cx="4206240" cy="731520"/>
-          </a:xfrm>
-          <a:prstGeom prst="rect">
-            <a:avLst/>
-          </a:prstGeom>
-          <a:noFill/>
-          <a:ln/>
-        </p:spPr>
-        <p:txBody>
-          <a:bodyPr wrap="square" lIns="0" tIns="0" rIns="0" bIns="0" rtlCol="0" anchor="ctr"/>
-          <a:lstStyle/>
-          <a:p>
-            <a:pPr indent="0" marL="0">
+            <a:off x="7127800" y="3825093"/>
+            <a:ext cx="4343400" cy="731520"/>
+          </a:xfrm>
+          <a:prstGeom prst="rect">
+            <a:avLst/>
+          </a:prstGeom>
+          <a:noFill/>
+          <a:ln/>
+        </p:spPr>
+        <p:txBody>
+          <a:bodyPr wrap="square" lIns="0" tIns="0" rIns="0" bIns="0" rtlCol="0" anchor="ctr"/>
+          <a:lstStyle/>
+          <a:p>
+            <a:pPr marL="0" indent="0">
               <a:buNone/>
             </a:pPr>
             <a:r>
@@ -7010,12 +7122,72 @@
                 <a:ea typeface="Calibri" pitchFamily="34" charset="-122"/>
                 <a:cs typeface="Calibri" pitchFamily="34" charset="-120"/>
               </a:rPr>
-              <a:t>Explains real records at 4, 24, and 88 qubits — scale-agnostic.</a:t>
+              <a:t>Explains real records at 4, 24, and 88 qubits - scale-agnostic.</a:t>
             </a:r>
             <a:endParaRPr lang="en-US" sz="1400" dirty="0"/>
           </a:p>
         </p:txBody>
       </p:sp>
+      <p:pic>
+        <p:nvPicPr>
+          <p:cNvPr id="26" name="Picture 25">
+            <a:extLst>
+              <a:ext uri="{FF2B5EF4-FFF2-40B4-BE49-F238E27FC236}">
+                <a16:creationId xmlns:a16="http://schemas.microsoft.com/office/drawing/2014/main" id="{768D4765-9E6D-E7EB-F01F-D733AD837434}"/>
+              </a:ext>
+            </a:extLst>
+          </p:cNvPr>
+          <p:cNvPicPr>
+            <a:picLocks noChangeAspect="1"/>
+          </p:cNvPicPr>
+          <p:nvPr/>
+        </p:nvPicPr>
+        <p:blipFill>
+          <a:blip r:embed="rId3"/>
+          <a:stretch>
+            <a:fillRect/>
+          </a:stretch>
+        </p:blipFill>
+        <p:spPr>
+          <a:xfrm>
+            <a:off x="815888" y="4700991"/>
+            <a:ext cx="4628804" cy="2085047"/>
+          </a:xfrm>
+          <a:prstGeom prst="rect">
+            <a:avLst/>
+          </a:prstGeom>
+        </p:spPr>
+      </p:pic>
+      <p:pic>
+        <p:nvPicPr>
+          <p:cNvPr id="28" name="Picture 27">
+            <a:extLst>
+              <a:ext uri="{FF2B5EF4-FFF2-40B4-BE49-F238E27FC236}">
+                <a16:creationId xmlns:a16="http://schemas.microsoft.com/office/drawing/2014/main" id="{2264056C-9CD1-8E09-4FAD-7C96571C6AA9}"/>
+              </a:ext>
+            </a:extLst>
+          </p:cNvPr>
+          <p:cNvPicPr>
+            <a:picLocks noChangeAspect="1"/>
+          </p:cNvPicPr>
+          <p:nvPr/>
+        </p:nvPicPr>
+        <p:blipFill>
+          <a:blip r:embed="rId4"/>
+          <a:stretch>
+            <a:fillRect/>
+          </a:stretch>
+        </p:blipFill>
+        <p:spPr>
+          <a:xfrm>
+            <a:off x="6747309" y="4658261"/>
+            <a:ext cx="4119613" cy="2047585"/>
+          </a:xfrm>
+          <a:prstGeom prst="rect">
+            <a:avLst/>
+          </a:prstGeom>
+        </p:spPr>
+      </p:pic>
     </p:spTree>
   </p:cSld>
   <p:clrMapOvr>
@@ -7032,6 +7204,7 @@
         <a:solidFill>
           <a:srgbClr val="071528"/>
         </a:solidFill>
+        <a:effectLst/>
       </p:bgPr>
     </p:bg>
     <p:spTree>
@@ -7069,6 +7242,13 @@
           </a:solidFill>
           <a:ln/>
         </p:spPr>
+        <p:txBody>
+          <a:bodyPr/>
+          <a:lstStyle/>
+          <a:p>
+            <a:endParaRPr lang="en-US"/>
+          </a:p>
+        </p:txBody>
       </p:sp>
       <p:sp>
         <p:nvSpPr>
@@ -7091,7 +7271,7 @@
           <a:bodyPr wrap="square" lIns="0" tIns="0" rIns="0" bIns="0" rtlCol="0" anchor="ctr"/>
           <a:lstStyle/>
           <a:p>
-            <a:pPr algn="ctr" indent="0" marL="0">
+            <a:pPr marL="0" indent="0" algn="ctr">
               <a:buNone/>
             </a:pPr>
             <a:r>
@@ -7130,7 +7310,7 @@
           <a:bodyPr wrap="square" lIns="0" tIns="0" rIns="0" bIns="0" rtlCol="0" anchor="ctr"/>
           <a:lstStyle/>
           <a:p>
-            <a:pPr indent="0" marL="0">
+            <a:pPr marL="0" indent="0">
               <a:buNone/>
             </a:pPr>
             <a:r>
@@ -7142,7 +7322,7 @@
                 <a:ea typeface="Cambria" pitchFamily="34" charset="-122"/>
                 <a:cs typeface="Cambria" pitchFamily="34" charset="-120"/>
               </a:rPr>
-              <a:t>Live seal verification — LEON, locally</a:t>
+              <a:t>Live seal verification – “LEON”, locally</a:t>
             </a:r>
             <a:endParaRPr lang="en-US" sz="3400" dirty="0"/>
           </a:p>
@@ -7156,8 +7336,8 @@
         </p:nvSpPr>
         <p:spPr>
           <a:xfrm>
-            <a:off x="640080" y="2011680"/>
-            <a:ext cx="5349240" cy="2468880"/>
+            <a:off x="640080" y="1823415"/>
+            <a:ext cx="5349240" cy="2208628"/>
           </a:xfrm>
           <a:prstGeom prst="roundRect">
             <a:avLst>
@@ -7174,13 +7354,21 @@
             <a:prstDash val="solid"/>
           </a:ln>
           <a:effectLst>
-            <a:outerShdw sx="100000" sy="100000" kx="0" ky="0" algn="bl" rotWithShape="0" blurRad="101600" dist="38100" dir="5400000">
+            <a:outerShdw blurRad="101600" dist="38100" dir="5400000" algn="bl" rotWithShape="0">
               <a:srgbClr val="071018">
                 <a:alpha val="45000"/>
               </a:srgbClr>
             </a:outerShdw>
           </a:effectLst>
         </p:spPr>
+        <p:txBody>
+          <a:bodyPr/>
+          <a:lstStyle/>
+          <a:p>
+            <a:pPr marL="0" algn="l" defTabSz="914400" rtl="0" eaLnBrk="1" latinLnBrk="0" hangingPunct="1"/>
+            <a:endParaRPr lang="en-US"/>
+          </a:p>
+        </p:txBody>
       </p:sp>
       <p:sp>
         <p:nvSpPr>
@@ -7190,7 +7378,7 @@
         </p:nvSpPr>
         <p:spPr>
           <a:xfrm>
-            <a:off x="914400" y="2331720"/>
+            <a:off x="914400" y="2026910"/>
             <a:ext cx="640080" cy="640080"/>
           </a:xfrm>
           <a:prstGeom prst="ellipse">
@@ -7201,6 +7389,13 @@
           </a:solidFill>
           <a:ln/>
         </p:spPr>
+        <p:txBody>
+          <a:bodyPr/>
+          <a:lstStyle/>
+          <a:p>
+            <a:endParaRPr lang="en-US"/>
+          </a:p>
+        </p:txBody>
       </p:sp>
       <p:sp>
         <p:nvSpPr>
@@ -7210,7 +7405,7 @@
         </p:nvSpPr>
         <p:spPr>
           <a:xfrm>
-            <a:off x="914400" y="2286000"/>
+            <a:off x="914400" y="2017050"/>
             <a:ext cx="640080" cy="640080"/>
           </a:xfrm>
           <a:prstGeom prst="rect">
@@ -7223,7 +7418,7 @@
           <a:bodyPr wrap="square" lIns="0" tIns="0" rIns="0" bIns="0" rtlCol="0" anchor="ctr"/>
           <a:lstStyle/>
           <a:p>
-            <a:pPr algn="ctr" indent="0" marL="0">
+            <a:pPr marL="0" indent="0" algn="ctr">
               <a:buNone/>
             </a:pPr>
             <a:r>
@@ -7249,7 +7444,7 @@
         </p:nvSpPr>
         <p:spPr>
           <a:xfrm>
-            <a:off x="1691640" y="2395728"/>
+            <a:off x="1691640" y="2126778"/>
             <a:ext cx="4023360" cy="548640"/>
           </a:xfrm>
           <a:prstGeom prst="rect">
@@ -7262,7 +7457,7 @@
           <a:bodyPr wrap="square" lIns="0" tIns="0" rIns="0" bIns="0" rtlCol="0" anchor="ctr"/>
           <a:lstStyle/>
           <a:p>
-            <a:pPr indent="0" marL="0">
+            <a:pPr marL="0" indent="0">
               <a:buNone/>
             </a:pPr>
             <a:r>
@@ -7288,20 +7483,20 @@
         </p:nvSpPr>
         <p:spPr>
           <a:xfrm>
-            <a:off x="914400" y="3200400"/>
-            <a:ext cx="4846320" cy="1097280"/>
-          </a:xfrm>
-          <a:prstGeom prst="rect">
-            <a:avLst/>
-          </a:prstGeom>
-          <a:noFill/>
-          <a:ln/>
-        </p:spPr>
-        <p:txBody>
-          <a:bodyPr wrap="square" lIns="0" tIns="0" rIns="0" bIns="0" rtlCol="0" anchor="ctr"/>
-          <a:lstStyle/>
-          <a:p>
-            <a:pPr indent="0" marL="0">
+            <a:off x="708660" y="2877660"/>
+            <a:ext cx="5280660" cy="1097280"/>
+          </a:xfrm>
+          <a:prstGeom prst="rect">
+            <a:avLst/>
+          </a:prstGeom>
+          <a:noFill/>
+          <a:ln/>
+        </p:spPr>
+        <p:txBody>
+          <a:bodyPr wrap="square" lIns="0" tIns="0" rIns="0" bIns="0" rtlCol="0" anchor="ctr"/>
+          <a:lstStyle/>
+          <a:p>
+            <a:pPr marL="0" indent="0">
               <a:buNone/>
             </a:pPr>
             <a:r>
@@ -7313,7 +7508,7 @@
                 <a:ea typeface="Calibri" pitchFamily="34" charset="-122"/>
                 <a:cs typeface="Calibri" pitchFamily="34" charset="-120"/>
               </a:rPr>
-              <a:t>Recomputed the SHA-256 seal over 37 fields; it matches the stored hash. The record is intact.</a:t>
+              <a:t>Recomputed the SHA-256 seal over 37 fields. it matches the stored hash. The record is intact.</a:t>
             </a:r>
             <a:endParaRPr lang="en-US" sz="1500" dirty="0"/>
           </a:p>
@@ -7327,8 +7522,8 @@
         </p:nvSpPr>
         <p:spPr>
           <a:xfrm>
-            <a:off x="6355080" y="2011680"/>
-            <a:ext cx="5212080" cy="2468880"/>
+            <a:off x="6355080" y="1823415"/>
+            <a:ext cx="5212080" cy="2208628"/>
           </a:xfrm>
           <a:prstGeom prst="roundRect">
             <a:avLst>
@@ -7345,13 +7540,21 @@
             <a:prstDash val="solid"/>
           </a:ln>
           <a:effectLst>
-            <a:outerShdw sx="100000" sy="100000" kx="0" ky="0" algn="bl" rotWithShape="0" blurRad="101600" dist="38100" dir="5400000">
+            <a:outerShdw blurRad="101600" dist="38100" dir="5400000" algn="bl" rotWithShape="0">
               <a:srgbClr val="071018">
                 <a:alpha val="45000"/>
               </a:srgbClr>
             </a:outerShdw>
           </a:effectLst>
         </p:spPr>
+        <p:txBody>
+          <a:bodyPr/>
+          <a:lstStyle/>
+          <a:p>
+            <a:pPr marL="0" algn="l" defTabSz="914400" rtl="0" eaLnBrk="1" latinLnBrk="0" hangingPunct="1"/>
+            <a:endParaRPr lang="en-US"/>
+          </a:p>
+        </p:txBody>
       </p:sp>
       <p:sp>
         <p:nvSpPr>
@@ -7361,7 +7564,7 @@
         </p:nvSpPr>
         <p:spPr>
           <a:xfrm>
-            <a:off x="6629400" y="2331720"/>
+            <a:off x="6629400" y="2026910"/>
             <a:ext cx="640080" cy="640080"/>
           </a:xfrm>
           <a:prstGeom prst="ellipse">
@@ -7372,6 +7575,13 @@
           </a:solidFill>
           <a:ln/>
         </p:spPr>
+        <p:txBody>
+          <a:bodyPr/>
+          <a:lstStyle/>
+          <a:p>
+            <a:endParaRPr lang="en-US"/>
+          </a:p>
+        </p:txBody>
       </p:sp>
       <p:sp>
         <p:nvSpPr>
@@ -7381,7 +7591,7 @@
         </p:nvSpPr>
         <p:spPr>
           <a:xfrm>
-            <a:off x="6629400" y="2286000"/>
+            <a:off x="6629400" y="2017050"/>
             <a:ext cx="640080" cy="640080"/>
           </a:xfrm>
           <a:prstGeom prst="rect">
@@ -7394,7 +7604,7 @@
           <a:bodyPr wrap="square" lIns="0" tIns="0" rIns="0" bIns="0" rtlCol="0" anchor="ctr"/>
           <a:lstStyle/>
           <a:p>
-            <a:pPr algn="ctr" indent="0" marL="0">
+            <a:pPr marL="0" indent="0" algn="ctr">
               <a:buNone/>
             </a:pPr>
             <a:r>
@@ -7420,7 +7630,7 @@
         </p:nvSpPr>
         <p:spPr>
           <a:xfrm>
-            <a:off x="7406640" y="2395728"/>
+            <a:off x="7406640" y="2126778"/>
             <a:ext cx="3931920" cy="548640"/>
           </a:xfrm>
           <a:prstGeom prst="rect">
@@ -7433,7 +7643,7 @@
           <a:bodyPr wrap="square" lIns="0" tIns="0" rIns="0" bIns="0" rtlCol="0" anchor="ctr"/>
           <a:lstStyle/>
           <a:p>
-            <a:pPr indent="0" marL="0">
+            <a:pPr marL="0" indent="0">
               <a:buNone/>
             </a:pPr>
             <a:r>
@@ -7459,20 +7669,20 @@
         </p:nvSpPr>
         <p:spPr>
           <a:xfrm>
-            <a:off x="6629400" y="3200400"/>
-            <a:ext cx="4663440" cy="1097280"/>
-          </a:xfrm>
-          <a:prstGeom prst="rect">
-            <a:avLst/>
-          </a:prstGeom>
-          <a:noFill/>
-          <a:ln/>
-        </p:spPr>
-        <p:txBody>
-          <a:bodyPr wrap="square" lIns="0" tIns="0" rIns="0" bIns="0" rtlCol="0" anchor="ctr"/>
-          <a:lstStyle/>
-          <a:p>
-            <a:pPr indent="0" marL="0">
+            <a:off x="6436659" y="2877660"/>
+            <a:ext cx="5115261" cy="1097280"/>
+          </a:xfrm>
+          <a:prstGeom prst="rect">
+            <a:avLst/>
+          </a:prstGeom>
+          <a:noFill/>
+          <a:ln/>
+        </p:spPr>
+        <p:txBody>
+          <a:bodyPr wrap="square" lIns="0" tIns="0" rIns="0" bIns="0" rtlCol="0" anchor="ctr"/>
+          <a:lstStyle/>
+          <a:p>
+            <a:pPr marL="0" indent="0">
               <a:buNone/>
             </a:pPr>
             <a:r>
@@ -7484,7 +7694,7 @@
                 <a:ea typeface="Calibri" pitchFamily="34" charset="-122"/>
                 <a:cs typeface="Calibri" pitchFamily="34" charset="-120"/>
               </a:rPr>
-              <a:t>Changed one digit of the energy — it caught the exact field: p7_energy_ha. Tamper detection, offline.</a:t>
+              <a:t>Changed one character/digit of the results - it catches the exact field. p7_energy_ha. Tamper detection, offline.</a:t>
             </a:r>
             <a:endParaRPr lang="en-US" sz="1500" dirty="0"/>
           </a:p>
@@ -7498,7 +7708,7 @@
         </p:nvSpPr>
         <p:spPr>
           <a:xfrm>
-            <a:off x="640080" y="4800600"/>
+            <a:off x="1783080" y="3966870"/>
             <a:ext cx="10972800" cy="457200"/>
           </a:xfrm>
           <a:prstGeom prst="rect">
@@ -7511,7 +7721,7 @@
           <a:bodyPr wrap="square" lIns="0" tIns="0" rIns="0" bIns="0" rtlCol="0" anchor="ctr"/>
           <a:lstStyle/>
           <a:p>
-            <a:pPr indent="0" marL="0">
+            <a:pPr marL="0" indent="0">
               <a:buNone/>
             </a:pPr>
             <a:r>
@@ -7523,12 +7733,72 @@
                 <a:ea typeface="Calibri" pitchFamily="34" charset="-122"/>
                 <a:cs typeface="Calibri" pitchFamily="34" charset="-120"/>
               </a:rPr>
-              <a:t>A faithful reproduction of the platform's notary — the practical embodiment of “verify, don't trust.”</a:t>
+              <a:t>A faithful reproduction of the platform's notary - the practical embodiment of “verify, don't trust.”</a:t>
             </a:r>
             <a:endParaRPr lang="en-US" sz="1600" dirty="0"/>
           </a:p>
         </p:txBody>
       </p:sp>
+      <p:pic>
+        <p:nvPicPr>
+          <p:cNvPr id="17" name="Picture 16">
+            <a:extLst>
+              <a:ext uri="{FF2B5EF4-FFF2-40B4-BE49-F238E27FC236}">
+                <a16:creationId xmlns:a16="http://schemas.microsoft.com/office/drawing/2014/main" id="{625135E1-27B4-0C18-B796-DAC7FD5F49B2}"/>
+              </a:ext>
+            </a:extLst>
+          </p:cNvPr>
+          <p:cNvPicPr>
+            <a:picLocks noChangeAspect="1"/>
+          </p:cNvPicPr>
+          <p:nvPr/>
+        </p:nvPicPr>
+        <p:blipFill>
+          <a:blip r:embed="rId3"/>
+          <a:stretch>
+            <a:fillRect/>
+          </a:stretch>
+        </p:blipFill>
+        <p:spPr>
+          <a:xfrm>
+            <a:off x="708659" y="4456630"/>
+            <a:ext cx="5113425" cy="2208628"/>
+          </a:xfrm>
+          <a:prstGeom prst="rect">
+            <a:avLst/>
+          </a:prstGeom>
+        </p:spPr>
+      </p:pic>
+      <p:pic>
+        <p:nvPicPr>
+          <p:cNvPr id="19" name="Picture 18">
+            <a:extLst>
+              <a:ext uri="{FF2B5EF4-FFF2-40B4-BE49-F238E27FC236}">
+                <a16:creationId xmlns:a16="http://schemas.microsoft.com/office/drawing/2014/main" id="{581F3722-416C-F3FD-1055-23334DDC3D71}"/>
+              </a:ext>
+            </a:extLst>
+          </p:cNvPr>
+          <p:cNvPicPr>
+            <a:picLocks noChangeAspect="1"/>
+          </p:cNvPicPr>
+          <p:nvPr/>
+        </p:nvPicPr>
+        <p:blipFill>
+          <a:blip r:embed="rId4"/>
+          <a:stretch>
+            <a:fillRect/>
+          </a:stretch>
+        </p:blipFill>
+        <p:spPr>
+          <a:xfrm>
+            <a:off x="6526306" y="4436233"/>
+            <a:ext cx="4937312" cy="2247838"/>
+          </a:xfrm>
+          <a:prstGeom prst="rect">
+            <a:avLst/>
+          </a:prstGeom>
+        </p:spPr>
+      </p:pic>
     </p:spTree>
   </p:cSld>
   <p:clrMapOvr>
@@ -7545,6 +7815,7 @@
         <a:solidFill>
           <a:srgbClr val="0B1E3D"/>
         </a:solidFill>
+        <a:effectLst/>
       </p:bgPr>
     </p:bg>
     <p:spTree>
@@ -7569,7 +7840,7 @@
         </p:nvSpPr>
         <p:spPr>
           <a:xfrm>
-            <a:off x="640080" y="502920"/>
+            <a:off x="640080" y="300795"/>
             <a:ext cx="1993392" cy="329184"/>
           </a:xfrm>
           <a:prstGeom prst="roundRect">
@@ -7582,6 +7853,13 @@
           </a:solidFill>
           <a:ln/>
         </p:spPr>
+        <p:txBody>
+          <a:bodyPr/>
+          <a:lstStyle/>
+          <a:p>
+            <a:endParaRPr lang="en-US"/>
+          </a:p>
+        </p:txBody>
       </p:sp>
       <p:sp>
         <p:nvSpPr>
@@ -7591,7 +7869,7 @@
         </p:nvSpPr>
         <p:spPr>
           <a:xfrm>
-            <a:off x="640080" y="502920"/>
+            <a:off x="640080" y="300795"/>
             <a:ext cx="1993392" cy="329184"/>
           </a:xfrm>
           <a:prstGeom prst="rect">
@@ -7604,7 +7882,7 @@
           <a:bodyPr wrap="square" lIns="0" tIns="0" rIns="0" bIns="0" rtlCol="0" anchor="ctr"/>
           <a:lstStyle/>
           <a:p>
-            <a:pPr algn="ctr" indent="0" marL="0">
+            <a:pPr marL="0" indent="0" algn="ctr">
               <a:buNone/>
             </a:pPr>
             <a:r>
@@ -7616,7 +7894,7 @@
                 <a:ea typeface="Calibri" pitchFamily="34" charset="-122"/>
                 <a:cs typeface="Calibri" pitchFamily="34" charset="-120"/>
               </a:rPr>
-              <a:t>Evaluation  [25 pts]</a:t>
+              <a:t>Evaluation </a:t>
             </a:r>
             <a:endParaRPr lang="en-US" sz="1200" dirty="0"/>
           </a:p>
@@ -7630,7 +7908,7 @@
         </p:nvSpPr>
         <p:spPr>
           <a:xfrm>
-            <a:off x="640080" y="868680"/>
+            <a:off x="640080" y="666555"/>
             <a:ext cx="10972800" cy="822960"/>
           </a:xfrm>
           <a:prstGeom prst="rect">
@@ -7643,7 +7921,7 @@
           <a:bodyPr wrap="square" lIns="0" tIns="0" rIns="0" bIns="0" rtlCol="0" anchor="ctr"/>
           <a:lstStyle/>
           <a:p>
-            <a:pPr indent="0" marL="0">
+            <a:pPr marL="0" indent="0">
               <a:buNone/>
             </a:pPr>
             <a:r>
@@ -7663,17 +7941,23 @@
       </p:sp>
       <p:graphicFrame>
         <p:nvGraphicFramePr>
-          <p:cNvPr id="5" name="Chart 0" descr=""/>
+          <p:cNvPr id="5" name="Chart 0"/>
           <p:cNvGraphicFramePr/>
-          <p:nvPr/>
+          <p:nvPr>
+            <p:extLst>
+              <p:ext uri="{D42A27DB-BD31-4B8C-83A1-F6EECF244321}">
+                <p14:modId xmlns:p14="http://schemas.microsoft.com/office/powerpoint/2010/main" val="1034164489"/>
+              </p:ext>
+            </p:extLst>
+          </p:nvPr>
         </p:nvGraphicFramePr>
         <p:xfrm>
-          <a:off x="640080" y="1920240"/>
+          <a:off x="221060" y="1544379"/>
           <a:ext cx="5760720" cy="4206240"/>
         </p:xfrm>
-        <a:graphic xmlns:a="http://schemas.openxmlformats.org/drawingml/2006/main">
+        <a:graphic>
           <a:graphicData uri="http://schemas.openxmlformats.org/drawingml/2006/chart">
-            <c:chart xmlns:c="http://schemas.openxmlformats.org/drawingml/2006/chart" r:id="rId1"/>
+            <c:chart xmlns:c="http://schemas.openxmlformats.org/drawingml/2006/chart" xmlns:r="http://schemas.openxmlformats.org/officeDocument/2006/relationships" r:id="rId3"/>
           </a:graphicData>
         </a:graphic>
       </p:graphicFrame>
@@ -7685,7 +7969,7 @@
         </p:nvSpPr>
         <p:spPr>
           <a:xfrm>
-            <a:off x="6720840" y="1965960"/>
+            <a:off x="7067350" y="287079"/>
             <a:ext cx="4846320" cy="1234440"/>
           </a:xfrm>
           <a:prstGeom prst="roundRect">
@@ -7703,13 +7987,20 @@
             <a:prstDash val="solid"/>
           </a:ln>
           <a:effectLst>
-            <a:outerShdw sx="100000" sy="100000" kx="0" ky="0" algn="bl" rotWithShape="0" blurRad="101600" dist="38100" dir="5400000">
+            <a:outerShdw blurRad="101600" dist="38100" dir="5400000" algn="bl" rotWithShape="0">
               <a:srgbClr val="071018">
                 <a:alpha val="45000"/>
               </a:srgbClr>
             </a:outerShdw>
           </a:effectLst>
         </p:spPr>
+        <p:txBody>
+          <a:bodyPr/>
+          <a:lstStyle/>
+          <a:p>
+            <a:endParaRPr lang="en-US"/>
+          </a:p>
+        </p:txBody>
       </p:sp>
       <p:sp>
         <p:nvSpPr>
@@ -7719,7 +8010,7 @@
         </p:nvSpPr>
         <p:spPr>
           <a:xfrm>
-            <a:off x="6949440" y="2103120"/>
+            <a:off x="7295950" y="424239"/>
             <a:ext cx="4389120" cy="411480"/>
           </a:xfrm>
           <a:prstGeom prst="rect">
@@ -7732,7 +8023,7 @@
           <a:bodyPr wrap="square" lIns="0" tIns="0" rIns="0" bIns="0" rtlCol="0" anchor="ctr"/>
           <a:lstStyle/>
           <a:p>
-            <a:pPr indent="0" marL="0">
+            <a:pPr marL="0" indent="0">
               <a:buNone/>
             </a:pPr>
             <a:r>
@@ -7758,7 +8049,7 @@
         </p:nvSpPr>
         <p:spPr>
           <a:xfrm>
-            <a:off x="6949440" y="2514600"/>
+            <a:off x="7295950" y="835719"/>
             <a:ext cx="4434840" cy="640080"/>
           </a:xfrm>
           <a:prstGeom prst="rect">
@@ -7771,7 +8062,7 @@
           <a:bodyPr wrap="square" lIns="0" tIns="0" rIns="0" bIns="0" rtlCol="0" anchor="ctr"/>
           <a:lstStyle/>
           <a:p>
-            <a:pPr indent="0" marL="0">
+            <a:pPr marL="0" indent="0">
               <a:buNone/>
             </a:pPr>
             <a:r>
@@ -7783,7 +8074,7 @@
                 <a:ea typeface="Calibri" pitchFamily="34" charset="-122"/>
                 <a:cs typeface="Calibri" pitchFamily="34" charset="-120"/>
               </a:rPr>
-              <a:t>Perfect on every quality metric and the fastest — ties the 8B model at ~12× lower latency.</a:t>
+              <a:t>Perfect on every quality metric and the fastest - ties the 8B model at ~12× lower latency.</a:t>
             </a:r>
             <a:endParaRPr lang="en-US" sz="1350" dirty="0"/>
           </a:p>
@@ -7797,7 +8088,7 @@
         </p:nvSpPr>
         <p:spPr>
           <a:xfrm>
-            <a:off x="6720840" y="3337560"/>
+            <a:off x="7067350" y="1658679"/>
             <a:ext cx="4846320" cy="1234440"/>
           </a:xfrm>
           <a:prstGeom prst="roundRect">
@@ -7815,13 +8106,20 @@
             <a:prstDash val="solid"/>
           </a:ln>
           <a:effectLst>
-            <a:outerShdw sx="100000" sy="100000" kx="0" ky="0" algn="bl" rotWithShape="0" blurRad="101600" dist="38100" dir="5400000">
+            <a:outerShdw blurRad="101600" dist="38100" dir="5400000" algn="bl" rotWithShape="0">
               <a:srgbClr val="071018">
                 <a:alpha val="45000"/>
               </a:srgbClr>
             </a:outerShdw>
           </a:effectLst>
         </p:spPr>
+        <p:txBody>
+          <a:bodyPr/>
+          <a:lstStyle/>
+          <a:p>
+            <a:endParaRPr lang="en-US"/>
+          </a:p>
+        </p:txBody>
       </p:sp>
       <p:sp>
         <p:nvSpPr>
@@ -7831,7 +8129,7 @@
         </p:nvSpPr>
         <p:spPr>
           <a:xfrm>
-            <a:off x="6949440" y="3474720"/>
+            <a:off x="7295950" y="1795839"/>
             <a:ext cx="4389120" cy="411480"/>
           </a:xfrm>
           <a:prstGeom prst="rect">
@@ -7844,7 +8142,7 @@
           <a:bodyPr wrap="square" lIns="0" tIns="0" rIns="0" bIns="0" rtlCol="0" anchor="ctr"/>
           <a:lstStyle/>
           <a:p>
-            <a:pPr indent="0" marL="0">
+            <a:pPr marL="0" indent="0">
               <a:buNone/>
             </a:pPr>
             <a:r>
@@ -7870,7 +8168,7 @@
         </p:nvSpPr>
         <p:spPr>
           <a:xfrm>
-            <a:off x="6949440" y="3886200"/>
+            <a:off x="7295950" y="2207319"/>
             <a:ext cx="4434840" cy="640080"/>
           </a:xfrm>
           <a:prstGeom prst="rect">
@@ -7883,7 +8181,7 @@
           <a:bodyPr wrap="square" lIns="0" tIns="0" rIns="0" bIns="0" rtlCol="0" anchor="ctr"/>
           <a:lstStyle/>
           <a:p>
-            <a:pPr indent="0" marL="0">
+            <a:pPr marL="0" indent="0">
               <a:buNone/>
             </a:pPr>
             <a:r>
@@ -7909,7 +8207,7 @@
         </p:nvSpPr>
         <p:spPr>
           <a:xfrm>
-            <a:off x="6720840" y="4709160"/>
+            <a:off x="7067350" y="3030279"/>
             <a:ext cx="4846320" cy="1234440"/>
           </a:xfrm>
           <a:prstGeom prst="roundRect">
@@ -7927,13 +8225,21 @@
             <a:prstDash val="solid"/>
           </a:ln>
           <a:effectLst>
-            <a:outerShdw sx="100000" sy="100000" kx="0" ky="0" algn="bl" rotWithShape="0" blurRad="101600" dist="38100" dir="5400000">
+            <a:outerShdw blurRad="101600" dist="38100" dir="5400000" algn="bl" rotWithShape="0">
               <a:srgbClr val="071018">
                 <a:alpha val="45000"/>
               </a:srgbClr>
             </a:outerShdw>
           </a:effectLst>
         </p:spPr>
+        <p:txBody>
+          <a:bodyPr/>
+          <a:lstStyle/>
+          <a:p>
+            <a:pPr marL="0" algn="r" defTabSz="914400" rtl="1" eaLnBrk="1" latinLnBrk="0" hangingPunct="1"/>
+            <a:endParaRPr lang="en-US"/>
+          </a:p>
+        </p:txBody>
       </p:sp>
       <p:sp>
         <p:nvSpPr>
@@ -7943,7 +8249,7 @@
         </p:nvSpPr>
         <p:spPr>
           <a:xfrm>
-            <a:off x="6949440" y="4846320"/>
+            <a:off x="7295950" y="3167439"/>
             <a:ext cx="4389120" cy="411480"/>
           </a:xfrm>
           <a:prstGeom prst="rect">
@@ -7956,7 +8262,7 @@
           <a:bodyPr wrap="square" lIns="0" tIns="0" rIns="0" bIns="0" rtlCol="0" anchor="ctr"/>
           <a:lstStyle/>
           <a:p>
-            <a:pPr indent="0" marL="0">
+            <a:pPr marL="0" indent="0">
               <a:buNone/>
             </a:pPr>
             <a:r>
@@ -7982,7 +8288,7 @@
         </p:nvSpPr>
         <p:spPr>
           <a:xfrm>
-            <a:off x="6949440" y="5257800"/>
+            <a:off x="7295950" y="3578919"/>
             <a:ext cx="4434840" cy="640080"/>
           </a:xfrm>
           <a:prstGeom prst="rect">
@@ -7995,7 +8301,7 @@
           <a:bodyPr wrap="square" lIns="0" tIns="0" rIns="0" bIns="0" rtlCol="0" anchor="ctr"/>
           <a:lstStyle/>
           <a:p>
-            <a:pPr indent="0" marL="0">
+            <a:pPr marL="0" indent="0">
               <a:buNone/>
             </a:pPr>
             <a:r>
@@ -8013,6 +8319,36 @@
           </a:p>
         </p:txBody>
       </p:sp>
+      <p:pic>
+        <p:nvPicPr>
+          <p:cNvPr id="16" name="Picture 15">
+            <a:extLst>
+              <a:ext uri="{FF2B5EF4-FFF2-40B4-BE49-F238E27FC236}">
+                <a16:creationId xmlns:a16="http://schemas.microsoft.com/office/drawing/2014/main" id="{34C8EB00-CFF5-6FA7-066F-7D2927D5FCD5}"/>
+              </a:ext>
+            </a:extLst>
+          </p:cNvPr>
+          <p:cNvPicPr>
+            <a:picLocks noChangeAspect="1"/>
+          </p:cNvPicPr>
+          <p:nvPr/>
+        </p:nvPicPr>
+        <p:blipFill>
+          <a:blip r:embed="rId4"/>
+          <a:stretch>
+            <a:fillRect/>
+          </a:stretch>
+        </p:blipFill>
+        <p:spPr>
+          <a:xfrm>
+            <a:off x="2979981" y="4264719"/>
+            <a:ext cx="5760720" cy="2517263"/>
+          </a:xfrm>
+          <a:prstGeom prst="rect">
+            <a:avLst/>
+          </a:prstGeom>
+        </p:spPr>
+      </p:pic>
     </p:spTree>
   </p:cSld>
   <p:clrMapOvr>
@@ -8029,6 +8365,7 @@
         <a:solidFill>
           <a:srgbClr val="0B1E3D"/>
         </a:solidFill>
+        <a:effectLst/>
       </p:bgPr>
     </p:bg>
     <p:spTree>
@@ -8066,6 +8403,13 @@
           </a:solidFill>
           <a:ln/>
         </p:spPr>
+        <p:txBody>
+          <a:bodyPr/>
+          <a:lstStyle/>
+          <a:p>
+            <a:endParaRPr lang="en-US"/>
+          </a:p>
+        </p:txBody>
       </p:sp>
       <p:sp>
         <p:nvSpPr>
@@ -8088,7 +8432,7 @@
           <a:bodyPr wrap="square" lIns="0" tIns="0" rIns="0" bIns="0" rtlCol="0" anchor="ctr"/>
           <a:lstStyle/>
           <a:p>
-            <a:pPr algn="ctr" indent="0" marL="0">
+            <a:pPr marL="0" indent="0" algn="ctr">
               <a:buNone/>
             </a:pPr>
             <a:r>
@@ -8127,7 +8471,7 @@
           <a:bodyPr wrap="square" lIns="0" tIns="0" rIns="0" bIns="0" rtlCol="0" anchor="ctr"/>
           <a:lstStyle/>
           <a:p>
-            <a:pPr indent="0" marL="0">
+            <a:pPr marL="0" indent="0">
               <a:buNone/>
             </a:pPr>
             <a:r>
@@ -8171,13 +8515,20 @@
             <a:prstDash val="solid"/>
           </a:ln>
           <a:effectLst>
-            <a:outerShdw sx="100000" sy="100000" kx="0" ky="0" algn="bl" rotWithShape="0" blurRad="101600" dist="38100" dir="5400000">
+            <a:outerShdw blurRad="101600" dist="38100" dir="5400000" algn="bl" rotWithShape="0">
               <a:srgbClr val="071018">
                 <a:alpha val="45000"/>
               </a:srgbClr>
             </a:outerShdw>
           </a:effectLst>
         </p:spPr>
+        <p:txBody>
+          <a:bodyPr/>
+          <a:lstStyle/>
+          <a:p>
+            <a:endParaRPr lang="en-US"/>
+          </a:p>
+        </p:txBody>
       </p:sp>
       <p:sp>
         <p:nvSpPr>
@@ -8200,7 +8551,7 @@
           <a:bodyPr wrap="square" lIns="0" tIns="0" rIns="0" bIns="0" rtlCol="0" anchor="ctr"/>
           <a:lstStyle/>
           <a:p>
-            <a:pPr indent="0" marL="0">
+            <a:pPr marL="0" indent="0">
               <a:buNone/>
             </a:pPr>
             <a:r>
@@ -8239,7 +8590,7 @@
           <a:bodyPr wrap="square" lIns="0" tIns="0" rIns="0" bIns="0" rtlCol="0" anchor="ctr"/>
           <a:lstStyle/>
           <a:p>
-            <a:pPr indent="0" marL="0">
+            <a:pPr marL="0" indent="0">
               <a:buNone/>
             </a:pPr>
             <a:r>
@@ -8251,7 +8602,7 @@
                 <a:ea typeface="Calibri" pitchFamily="34" charset="-122"/>
                 <a:cs typeface="Calibri" pitchFamily="34" charset="-120"/>
               </a:rPr>
-              <a:t>std-dev at temperature 0 — fully deterministic, bit-for-bit reproducible</a:t>
+              <a:t>std-dev at temperature 0 - fully deterministic, bit-for-bit reproducible</a:t>
             </a:r>
             <a:endParaRPr lang="en-US" sz="1500" dirty="0"/>
           </a:p>
@@ -8283,13 +8634,20 @@
             <a:prstDash val="solid"/>
           </a:ln>
           <a:effectLst>
-            <a:outerShdw sx="100000" sy="100000" kx="0" ky="0" algn="bl" rotWithShape="0" blurRad="101600" dist="38100" dir="5400000">
+            <a:outerShdw blurRad="101600" dist="38100" dir="5400000" algn="bl" rotWithShape="0">
               <a:srgbClr val="071018">
                 <a:alpha val="45000"/>
               </a:srgbClr>
             </a:outerShdw>
           </a:effectLst>
         </p:spPr>
+        <p:txBody>
+          <a:bodyPr/>
+          <a:lstStyle/>
+          <a:p>
+            <a:endParaRPr lang="en-US"/>
+          </a:p>
+        </p:txBody>
       </p:sp>
       <p:sp>
         <p:nvSpPr>
@@ -8312,7 +8670,7 @@
           <a:bodyPr wrap="square" lIns="0" tIns="0" rIns="0" bIns="0" rtlCol="0" anchor="ctr"/>
           <a:lstStyle/>
           <a:p>
-            <a:pPr indent="0" marL="0">
+            <a:pPr marL="0" indent="0">
               <a:buNone/>
             </a:pPr>
             <a:r>
@@ -8351,7 +8709,7 @@
           <a:bodyPr wrap="square" lIns="0" tIns="0" rIns="0" bIns="0" rtlCol="0" anchor="ctr"/>
           <a:lstStyle/>
           <a:p>
-            <a:pPr indent="0" marL="0">
+            <a:pPr marL="0" indent="0">
               <a:buNone/>
             </a:pPr>
             <a:r>
@@ -8395,13 +8753,20 @@
             <a:prstDash val="solid"/>
           </a:ln>
           <a:effectLst>
-            <a:outerShdw sx="100000" sy="100000" kx="0" ky="0" algn="bl" rotWithShape="0" blurRad="101600" dist="38100" dir="5400000">
+            <a:outerShdw blurRad="101600" dist="38100" dir="5400000" algn="bl" rotWithShape="0">
               <a:srgbClr val="071018">
                 <a:alpha val="45000"/>
               </a:srgbClr>
             </a:outerShdw>
           </a:effectLst>
         </p:spPr>
+        <p:txBody>
+          <a:bodyPr/>
+          <a:lstStyle/>
+          <a:p>
+            <a:endParaRPr lang="en-US"/>
+          </a:p>
+        </p:txBody>
       </p:sp>
       <p:sp>
         <p:nvSpPr>
@@ -8424,7 +8789,7 @@
           <a:bodyPr wrap="square" lIns="0" tIns="0" rIns="0" bIns="0" rtlCol="0" anchor="ctr"/>
           <a:lstStyle/>
           <a:p>
-            <a:pPr indent="0" marL="0">
+            <a:pPr marL="0" indent="0">
               <a:buNone/>
             </a:pPr>
             <a:r>
@@ -8463,7 +8828,7 @@
           <a:bodyPr wrap="square" lIns="0" tIns="0" rIns="0" bIns="0" rtlCol="0" anchor="ctr"/>
           <a:lstStyle/>
           <a:p>
-            <a:pPr indent="0" marL="0">
+            <a:pPr marL="0" indent="0">
               <a:buNone/>
             </a:pPr>
             <a:r>
@@ -8475,7 +8840,7 @@
                 <a:ea typeface="Calibri" pitchFamily="34" charset="-122"/>
                 <a:cs typeface="Calibri" pitchFamily="34" charset="-120"/>
               </a:rPr>
-              <a:t>higher temperature adds variability — with no gain in accuracy</a:t>
+              <a:t>higher temperature adds variability with no gain in accuracy</a:t>
             </a:r>
             <a:endParaRPr lang="en-US" sz="1500" dirty="0"/>
           </a:p>
@@ -8502,7 +8867,7 @@
           <a:bodyPr wrap="square" lIns="0" tIns="0" rIns="0" bIns="0" rtlCol="0" anchor="ctr"/>
           <a:lstStyle/>
           <a:p>
-            <a:pPr indent="0" marL="0">
+            <a:pPr marL="0" indent="0">
               <a:buNone/>
             </a:pPr>
             <a:r>
@@ -8821,4 +9186,319 @@
     </a:ext>
   </a:extLst>
 </a:theme>
+</file>
+
+<file path=ppt/theme/theme2.xml><?xml version="1.0" encoding="utf-8"?>
+<a:theme xmlns:a="http://schemas.openxmlformats.org/drawingml/2006/main" name="Office Theme">
+  <a:themeElements>
+    <a:clrScheme name="Office">
+      <a:dk1>
+        <a:sysClr val="windowText" lastClr="000000"/>
+      </a:dk1>
+      <a:lt1>
+        <a:sysClr val="window" lastClr="FFFFFF"/>
+      </a:lt1>
+      <a:dk2>
+        <a:srgbClr val="0E2841"/>
+      </a:dk2>
+      <a:lt2>
+        <a:srgbClr val="E8E8E8"/>
+      </a:lt2>
+      <a:accent1>
+        <a:srgbClr val="156082"/>
+      </a:accent1>
+      <a:accent2>
+        <a:srgbClr val="E97132"/>
+      </a:accent2>
+      <a:accent3>
+        <a:srgbClr val="196B24"/>
+      </a:accent3>
+      <a:accent4>
+        <a:srgbClr val="0F9ED5"/>
+      </a:accent4>
+      <a:accent5>
+        <a:srgbClr val="A02B93"/>
+      </a:accent5>
+      <a:accent6>
+        <a:srgbClr val="4EA72E"/>
+      </a:accent6>
+      <a:hlink>
+        <a:srgbClr val="467886"/>
+      </a:hlink>
+      <a:folHlink>
+        <a:srgbClr val="96607D"/>
+      </a:folHlink>
+    </a:clrScheme>
+    <a:fontScheme name="Office">
+      <a:majorFont>
+        <a:latin typeface="Aptos Display" panose="02110004020202020204"/>
+        <a:ea typeface=""/>
+        <a:cs typeface=""/>
+        <a:font script="Jpan" typeface="游ゴシック Light"/>
+        <a:font script="Hang" typeface="맑은 고딕"/>
+        <a:font script="Hans" typeface="等线 Light"/>
+        <a:font script="Hant" typeface="新細明體"/>
+        <a:font script="Arab" typeface="Times New Roman"/>
+        <a:font script="Hebr" typeface="Times New Roman"/>
+        <a:font script="Thai" typeface="Angsana New"/>
+        <a:font script="Ethi" typeface="Nyala"/>
+        <a:font script="Beng" typeface="Vrinda"/>
+        <a:font script="Gujr" typeface="Shruti"/>
+        <a:font script="Khmr" typeface="MoolBoran"/>
+        <a:font script="Knda" typeface="Tunga"/>
+        <a:font script="Guru" typeface="Raavi"/>
+        <a:font script="Cans" typeface="Euphemia"/>
+        <a:font script="Cher" typeface="Plantagenet Cherokee"/>
+        <a:font script="Yiii" typeface="Microsoft Yi Baiti"/>
+        <a:font script="Tibt" typeface="Microsoft Himalaya"/>
+        <a:font script="Thaa" typeface="MV Boli"/>
+        <a:font script="Deva" typeface="Mangal"/>
+        <a:font script="Telu" typeface="Gautami"/>
+        <a:font script="Taml" typeface="Latha"/>
+        <a:font script="Syrc" typeface="Estrangelo Edessa"/>
+        <a:font script="Orya" typeface="Kalinga"/>
+        <a:font script="Mlym" typeface="Kartika"/>
+        <a:font script="Laoo" typeface="DokChampa"/>
+        <a:font script="Sinh" typeface="Iskoola Pota"/>
+        <a:font script="Mong" typeface="Mongolian Baiti"/>
+        <a:font script="Viet" typeface="Times New Roman"/>
+        <a:font script="Uigh" typeface="Microsoft Uighur"/>
+        <a:font script="Geor" typeface="Sylfaen"/>
+        <a:font script="Armn" typeface="Arial"/>
+        <a:font script="Bugi" typeface="Leelawadee UI"/>
+        <a:font script="Bopo" typeface="Microsoft JhengHei"/>
+        <a:font script="Java" typeface="Javanese Text"/>
+        <a:font script="Lisu" typeface="Segoe UI"/>
+        <a:font script="Mymr" typeface="Myanmar Text"/>
+        <a:font script="Nkoo" typeface="Ebrima"/>
+        <a:font script="Olck" typeface="Nirmala UI"/>
+        <a:font script="Osma" typeface="Ebrima"/>
+        <a:font script="Phag" typeface="Phagspa"/>
+        <a:font script="Syrn" typeface="Estrangelo Edessa"/>
+        <a:font script="Syrj" typeface="Estrangelo Edessa"/>
+        <a:font script="Syre" typeface="Estrangelo Edessa"/>
+        <a:font script="Sora" typeface="Nirmala UI"/>
+        <a:font script="Tale" typeface="Microsoft Tai Le"/>
+        <a:font script="Talu" typeface="Microsoft New Tai Lue"/>
+        <a:font script="Tfng" typeface="Ebrima"/>
+      </a:majorFont>
+      <a:minorFont>
+        <a:latin typeface="Aptos" panose="02110004020202020204"/>
+        <a:ea typeface=""/>
+        <a:cs typeface=""/>
+        <a:font script="Jpan" typeface="游ゴシック"/>
+        <a:font script="Hang" typeface="맑은 고딕"/>
+        <a:font script="Hans" typeface="等线"/>
+        <a:font script="Hant" typeface="新細明體"/>
+        <a:font script="Arab" typeface="Arial"/>
+        <a:font script="Hebr" typeface="Arial"/>
+        <a:font script="Thai" typeface="Cordia New"/>
+        <a:font script="Ethi" typeface="Nyala"/>
+        <a:font script="Beng" typeface="Vrinda"/>
+        <a:font script="Gujr" typeface="Shruti"/>
+        <a:font script="Khmr" typeface="DaunPenh"/>
+        <a:font script="Knda" typeface="Tunga"/>
+        <a:font script="Guru" typeface="Raavi"/>
+        <a:font script="Cans" typeface="Euphemia"/>
+        <a:font script="Cher" typeface="Plantagenet Cherokee"/>
+        <a:font script="Yiii" typeface="Microsoft Yi Baiti"/>
+        <a:font script="Tibt" typeface="Microsoft Himalaya"/>
+        <a:font script="Thaa" typeface="MV Boli"/>
+        <a:font script="Deva" typeface="Mangal"/>
+        <a:font script="Telu" typeface="Gautami"/>
+        <a:font script="Taml" typeface="Latha"/>
+        <a:font script="Syrc" typeface="Estrangelo Edessa"/>
+        <a:font script="Orya" typeface="Kalinga"/>
+        <a:font script="Mlym" typeface="Kartika"/>
+        <a:font script="Laoo" typeface="DokChampa"/>
+        <a:font script="Sinh" typeface="Iskoola Pota"/>
+        <a:font script="Mong" typeface="Mongolian Baiti"/>
+        <a:font script="Viet" typeface="Arial"/>
+        <a:font script="Uigh" typeface="Microsoft Uighur"/>
+        <a:font script="Geor" typeface="Sylfaen"/>
+        <a:font script="Armn" typeface="Arial"/>
+        <a:font script="Bugi" typeface="Leelawadee UI"/>
+        <a:font script="Bopo" typeface="Microsoft JhengHei"/>
+        <a:font script="Java" typeface="Javanese Text"/>
+        <a:font script="Lisu" typeface="Segoe UI"/>
+        <a:font script="Mymr" typeface="Myanmar Text"/>
+        <a:font script="Nkoo" typeface="Ebrima"/>
+        <a:font script="Olck" typeface="Nirmala UI"/>
+        <a:font script="Osma" typeface="Ebrima"/>
+        <a:font script="Phag" typeface="Phagspa"/>
+        <a:font script="Syrn" typeface="Estrangelo Edessa"/>
+        <a:font script="Syrj" typeface="Estrangelo Edessa"/>
+        <a:font script="Syre" typeface="Estrangelo Edessa"/>
+        <a:font script="Sora" typeface="Nirmala UI"/>
+        <a:font script="Tale" typeface="Microsoft Tai Le"/>
+        <a:font script="Talu" typeface="Microsoft New Tai Lue"/>
+        <a:font script="Tfng" typeface="Ebrima"/>
+      </a:minorFont>
+    </a:fontScheme>
+    <a:fmtScheme name="Office">
+      <a:fillStyleLst>
+        <a:solidFill>
+          <a:schemeClr val="phClr"/>
+        </a:solidFill>
+        <a:gradFill rotWithShape="1">
+          <a:gsLst>
+            <a:gs pos="0">
+              <a:schemeClr val="phClr">
+                <a:lumMod val="110000"/>
+                <a:satMod val="105000"/>
+                <a:tint val="67000"/>
+              </a:schemeClr>
+            </a:gs>
+            <a:gs pos="50000">
+              <a:schemeClr val="phClr">
+                <a:lumMod val="105000"/>
+                <a:satMod val="103000"/>
+                <a:tint val="73000"/>
+              </a:schemeClr>
+            </a:gs>
+            <a:gs pos="100000">
+              <a:schemeClr val="phClr">
+                <a:lumMod val="105000"/>
+                <a:satMod val="109000"/>
+                <a:tint val="81000"/>
+              </a:schemeClr>
+            </a:gs>
+          </a:gsLst>
+          <a:lin ang="5400000" scaled="0"/>
+        </a:gradFill>
+        <a:gradFill rotWithShape="1">
+          <a:gsLst>
+            <a:gs pos="0">
+              <a:schemeClr val="phClr">
+                <a:satMod val="103000"/>
+                <a:lumMod val="102000"/>
+                <a:tint val="94000"/>
+              </a:schemeClr>
+            </a:gs>
+            <a:gs pos="50000">
+              <a:schemeClr val="phClr">
+                <a:satMod val="110000"/>
+                <a:lumMod val="100000"/>
+                <a:shade val="100000"/>
+              </a:schemeClr>
+            </a:gs>
+            <a:gs pos="100000">
+              <a:schemeClr val="phClr">
+                <a:lumMod val="99000"/>
+                <a:satMod val="120000"/>
+                <a:shade val="78000"/>
+              </a:schemeClr>
+            </a:gs>
+          </a:gsLst>
+          <a:lin ang="5400000" scaled="0"/>
+        </a:gradFill>
+      </a:fillStyleLst>
+      <a:lnStyleLst>
+        <a:ln w="12700" cap="flat" cmpd="sng" algn="ctr">
+          <a:solidFill>
+            <a:schemeClr val="phClr"/>
+          </a:solidFill>
+          <a:prstDash val="solid"/>
+          <a:miter lim="800000"/>
+        </a:ln>
+        <a:ln w="19050" cap="flat" cmpd="sng" algn="ctr">
+          <a:solidFill>
+            <a:schemeClr val="phClr"/>
+          </a:solidFill>
+          <a:prstDash val="solid"/>
+          <a:miter lim="800000"/>
+        </a:ln>
+        <a:ln w="25400" cap="flat" cmpd="sng" algn="ctr">
+          <a:solidFill>
+            <a:schemeClr val="phClr"/>
+          </a:solidFill>
+          <a:prstDash val="solid"/>
+          <a:miter lim="800000"/>
+        </a:ln>
+      </a:lnStyleLst>
+      <a:effectStyleLst>
+        <a:effectStyle>
+          <a:effectLst/>
+        </a:effectStyle>
+        <a:effectStyle>
+          <a:effectLst/>
+        </a:effectStyle>
+        <a:effectStyle>
+          <a:effectLst>
+            <a:outerShdw blurRad="57150" dist="19050" dir="5400000" algn="ctr" rotWithShape="0">
+              <a:srgbClr val="000000">
+                <a:alpha val="63000"/>
+              </a:srgbClr>
+            </a:outerShdw>
+          </a:effectLst>
+        </a:effectStyle>
+      </a:effectStyleLst>
+      <a:bgFillStyleLst>
+        <a:solidFill>
+          <a:schemeClr val="phClr"/>
+        </a:solidFill>
+        <a:solidFill>
+          <a:schemeClr val="phClr">
+            <a:tint val="95000"/>
+            <a:satMod val="170000"/>
+          </a:schemeClr>
+        </a:solidFill>
+        <a:gradFill rotWithShape="1">
+          <a:gsLst>
+            <a:gs pos="0">
+              <a:schemeClr val="phClr">
+                <a:tint val="93000"/>
+                <a:satMod val="150000"/>
+                <a:shade val="98000"/>
+                <a:lumMod val="102000"/>
+              </a:schemeClr>
+            </a:gs>
+            <a:gs pos="50000">
+              <a:schemeClr val="phClr">
+                <a:tint val="98000"/>
+                <a:satMod val="130000"/>
+                <a:shade val="90000"/>
+                <a:lumMod val="103000"/>
+              </a:schemeClr>
+            </a:gs>
+            <a:gs pos="100000">
+              <a:schemeClr val="phClr">
+                <a:shade val="63000"/>
+                <a:satMod val="120000"/>
+              </a:schemeClr>
+            </a:gs>
+          </a:gsLst>
+          <a:lin ang="5400000" scaled="0"/>
+        </a:gradFill>
+      </a:bgFillStyleLst>
+    </a:fmtScheme>
+  </a:themeElements>
+  <a:objectDefaults>
+    <a:lnDef>
+      <a:spPr/>
+      <a:bodyPr/>
+      <a:lstStyle/>
+      <a:style>
+        <a:lnRef idx="2">
+          <a:schemeClr val="accent1"/>
+        </a:lnRef>
+        <a:fillRef idx="0">
+          <a:schemeClr val="accent1"/>
+        </a:fillRef>
+        <a:effectRef idx="1">
+          <a:schemeClr val="accent1"/>
+        </a:effectRef>
+        <a:fontRef idx="minor">
+          <a:schemeClr val="tx1"/>
+        </a:fontRef>
+      </a:style>
+    </a:lnDef>
+  </a:objectDefaults>
+  <a:extraClrSchemeLst/>
+  <a:extLst>
+    <a:ext uri="{05A4C25C-085E-4340-85A3-A5531E510DB2}">
+      <thm15:themeFamily xmlns:thm15="http://schemas.microsoft.com/office/thememl/2012/main" name="Office Theme" id="{2E142A2C-CD16-42D6-873A-C26D2A0506FA}" vid="{1BDDFF52-6CD6-40A5-AB3C-68EB2F1E4D0A}"/>
+    </a:ext>
+  </a:extLst>
+</a:theme>
 </file>
</xml_diff>